<commit_message>
feat(security): ✨ enhance security checks and supply chain protection
- make security gate blocking on HIGH/CRITICAL findings
- add SBOM generation and vulnerability scanning
- implement dependency confusion detection for PyPI and npm
- verify lockfile integrity and container image digest pinning
- expand security engineer instructions and checklist
</commit_message>
<xml_diff>
--- a/build/vibe-to-live-deck.pptx
+++ b/build/vibe-to-live-deck.pptx
@@ -47,38 +47,39 @@
     <p:sldId id="294" r:id="rId41"/>
     <p:sldId id="295" r:id="rId42"/>
     <p:sldId id="296" r:id="rId43"/>
-    <p:sldId id="297" r:id="rId44"/>
-    <p:sldId id="298" r:id="rId45"/>
-    <p:sldId id="299" r:id="rId46"/>
-    <p:sldId id="300" r:id="rId47"/>
-    <p:sldId id="301" r:id="rId48"/>
-    <p:sldId id="302" r:id="rId49"/>
-    <p:sldId id="303" r:id="rId50"/>
-    <p:sldId id="304" r:id="rId51"/>
-    <p:sldId id="305" r:id="rId52"/>
-    <p:sldId id="306" r:id="rId53"/>
-    <p:sldId id="307" r:id="rId54"/>
-    <p:sldId id="308" r:id="rId55"/>
-    <p:sldId id="309" r:id="rId56"/>
-    <p:sldId id="310" r:id="rId57"/>
-    <p:sldId id="311" r:id="rId58"/>
-    <p:sldId id="312" r:id="rId59"/>
-    <p:sldId id="313" r:id="rId60"/>
-    <p:sldId id="314" r:id="rId61"/>
-    <p:sldId id="315" r:id="rId62"/>
-    <p:sldId id="316" r:id="rId63"/>
-    <p:sldId id="317" r:id="rId64"/>
-    <p:sldId id="318" r:id="rId65"/>
-    <p:sldId id="319" r:id="rId66"/>
-    <p:sldId id="320" r:id="rId67"/>
-    <p:sldId id="321" r:id="rId68"/>
-    <p:sldId id="322" r:id="rId69"/>
-    <p:sldId id="323" r:id="rId70"/>
-    <p:sldId id="324" r:id="rId71"/>
-    <p:sldId id="325" r:id="rId72"/>
-    <p:sldId id="326" r:id="rId73"/>
-    <p:sldId id="327" r:id="rId74"/>
-    <p:sldId id="328" r:id="rId75"/>
+    <p:sldId id="330" r:id="rId44"/>
+    <p:sldId id="297" r:id="rId45"/>
+    <p:sldId id="298" r:id="rId46"/>
+    <p:sldId id="299" r:id="rId47"/>
+    <p:sldId id="300" r:id="rId48"/>
+    <p:sldId id="301" r:id="rId49"/>
+    <p:sldId id="302" r:id="rId50"/>
+    <p:sldId id="303" r:id="rId51"/>
+    <p:sldId id="304" r:id="rId52"/>
+    <p:sldId id="305" r:id="rId53"/>
+    <p:sldId id="306" r:id="rId54"/>
+    <p:sldId id="307" r:id="rId55"/>
+    <p:sldId id="308" r:id="rId56"/>
+    <p:sldId id="309" r:id="rId57"/>
+    <p:sldId id="310" r:id="rId58"/>
+    <p:sldId id="311" r:id="rId59"/>
+    <p:sldId id="312" r:id="rId60"/>
+    <p:sldId id="313" r:id="rId61"/>
+    <p:sldId id="314" r:id="rId62"/>
+    <p:sldId id="315" r:id="rId63"/>
+    <p:sldId id="316" r:id="rId64"/>
+    <p:sldId id="317" r:id="rId65"/>
+    <p:sldId id="318" r:id="rId66"/>
+    <p:sldId id="319" r:id="rId67"/>
+    <p:sldId id="320" r:id="rId68"/>
+    <p:sldId id="321" r:id="rId69"/>
+    <p:sldId id="322" r:id="rId70"/>
+    <p:sldId id="323" r:id="rId71"/>
+    <p:sldId id="324" r:id="rId72"/>
+    <p:sldId id="325" r:id="rId73"/>
+    <p:sldId id="326" r:id="rId74"/>
+    <p:sldId id="327" r:id="rId75"/>
+    <p:sldId id="328" r:id="rId76"/>
   </p:sldIdLst>
   <p:sldSz cx="9144000" cy="5143500" type="screen16x9"/>
   <p:notesSz cx="6858000" cy="9144000"/>
@@ -5030,7 +5031,7 @@
         </p:nvGraphicFramePr>
         <p:xfrm>
           <a:off x="3568700" y="203200"/>
-          <a:ext cx="5105400" cy="4381500"/>
+          <a:ext cx="5105400" cy="4023360"/>
         </p:xfrm>
         <a:graphic>
           <a:graphicData uri="http://schemas.openxmlformats.org/drawingml/2006/table">
@@ -5737,7 +5738,7 @@
         </p:nvGraphicFramePr>
         <p:xfrm>
           <a:off x="457200" y="1193800"/>
-          <a:ext cx="8229600" cy="3390900"/>
+          <a:ext cx="8229600" cy="2377440"/>
         </p:xfrm>
         <a:graphic>
           <a:graphicData uri="http://schemas.openxmlformats.org/drawingml/2006/table">
@@ -9658,7 +9659,7 @@
         </p:nvGraphicFramePr>
         <p:xfrm>
           <a:off x="3568700" y="203200"/>
-          <a:ext cx="5105400" cy="4381500"/>
+          <a:ext cx="5080000" cy="4892040"/>
         </p:xfrm>
         <a:graphic>
           <a:graphicData uri="http://schemas.openxmlformats.org/drawingml/2006/table">
@@ -10927,7 +10928,13 @@
   <p:cSld>
     <p:spTree>
       <p:nvGrpSpPr>
-        <p:cNvPr id="1" name=""/>
+        <p:cNvPr id="1" name="">
+          <a:extLst>
+            <a:ext uri="{FF2B5EF4-FFF2-40B4-BE49-F238E27FC236}">
+              <a16:creationId xmlns:a16="http://schemas.microsoft.com/office/drawing/2014/main" id="{C3AFD2AA-0387-9774-E830-47D8F42615C9}"/>
+            </a:ext>
+          </a:extLst>
+        </p:cNvPr>
         <p:cNvGrpSpPr/>
         <p:nvPr/>
       </p:nvGrpSpPr>
@@ -10941,7 +10948,13 @@
       </p:grpSpPr>
       <p:sp>
         <p:nvSpPr>
-          <p:cNvPr id="2" name="Title 1"/>
+          <p:cNvPr id="2" name="Title 1">
+            <a:extLst>
+              <a:ext uri="{FF2B5EF4-FFF2-40B4-BE49-F238E27FC236}">
+                <a16:creationId xmlns:a16="http://schemas.microsoft.com/office/drawing/2014/main" id="{70DD6B9A-9A70-7B38-6280-463D2050EC38}"/>
+              </a:ext>
+            </a:extLst>
+          </p:cNvPr>
           <p:cNvSpPr>
             <a:spLocks noGrp="1"/>
           </p:cNvSpPr>
@@ -10954,18 +10967,35 @@
           <a:bodyPr/>
           <a:lstStyle/>
           <a:p>
-            <a:pPr marL="0" lvl="0" indent="0">
-              <a:buNone/>
-            </a:pPr>
-            <a:r>
-              <a:t>The Paradox</a:t>
-            </a:r>
-          </a:p>
-        </p:txBody>
-      </p:sp>
-      <p:sp>
-        <p:nvSpPr>
-          <p:cNvPr id="3" name="Content Placeholder 2"/>
+            <a:r>
+              <a:rPr lang="de-DE" dirty="0"/>
+              <a:t>Supply Chain </a:t>
+            </a:r>
+            <a:r>
+              <a:rPr lang="de-DE" dirty="0" err="1"/>
+              <a:t>Attack</a:t>
+            </a:r>
+            <a:r>
+              <a:rPr lang="de-DE" dirty="0"/>
+              <a:t> </a:t>
+            </a:r>
+            <a:r>
+              <a:rPr lang="de-DE" dirty="0" err="1"/>
+              <a:t>Detection</a:t>
+            </a:r>
+            <a:endParaRPr lang="de-DE" dirty="0"/>
+          </a:p>
+        </p:txBody>
+      </p:sp>
+      <p:sp>
+        <p:nvSpPr>
+          <p:cNvPr id="3" name="Content Placeholder 2">
+            <a:extLst>
+              <a:ext uri="{FF2B5EF4-FFF2-40B4-BE49-F238E27FC236}">
+                <a16:creationId xmlns:a16="http://schemas.microsoft.com/office/drawing/2014/main" id="{08DE126C-5780-14F2-E53A-59884DE2CA09}"/>
+              </a:ext>
+            </a:extLst>
+          </p:cNvPr>
           <p:cNvSpPr>
             <a:spLocks noGrp="1"/>
           </p:cNvSpPr>
@@ -10975,27 +11005,578 @@
         </p:nvSpPr>
         <p:spPr/>
         <p:txBody>
-          <a:bodyPr/>
+          <a:bodyPr>
+            <a:normAutofit/>
+          </a:bodyPr>
           <a:lstStyle/>
           <a:p>
             <a:pPr marL="0" lvl="0" indent="0">
-              <a:buNone/>
-            </a:pPr>
-            <a:r>
-              <a:t>AI is both the problem and part of the solution. It introduces vulnerabilities faster than humans, but AI-powered scanners can also review code at machine speed and catch bugs people miss.</a:t>
-            </a:r>
-          </a:p>
-          <a:p>
-            <a:pPr marL="0" lvl="0" indent="0">
-              <a:buNone/>
-            </a:pPr>
-            <a:r>
-              <a:t>The future of secure vibe coding is not human or AI. It’s both layers working together.</a:t>
-            </a:r>
-          </a:p>
-        </p:txBody>
-      </p:sp>
+              <a:spcBef>
+                <a:spcPts val="3000"/>
+              </a:spcBef>
+              <a:buNone/>
+            </a:pPr>
+            <a:r>
+              <a:rPr b="1"/>
+              <a:t>Checklist</a:t>
+            </a:r>
+            <a:endParaRPr lang="en-US" b="1" dirty="0"/>
+          </a:p>
+          <a:p>
+            <a:pPr marL="0" lvl="0" indent="0">
+              <a:spcBef>
+                <a:spcPts val="3000"/>
+              </a:spcBef>
+              <a:buNone/>
+            </a:pPr>
+            <a:endParaRPr b="1" dirty="0"/>
+          </a:p>
+        </p:txBody>
+      </p:sp>
+      <p:graphicFrame>
+        <p:nvGraphicFramePr>
+          <p:cNvPr id="4" name="Tabelle 3">
+            <a:extLst>
+              <a:ext uri="{FF2B5EF4-FFF2-40B4-BE49-F238E27FC236}">
+                <a16:creationId xmlns:a16="http://schemas.microsoft.com/office/drawing/2014/main" id="{3AD2EE87-7965-EC12-ADFF-1D1F1A8CE1C5}"/>
+              </a:ext>
+            </a:extLst>
+          </p:cNvPr>
+          <p:cNvGraphicFramePr>
+            <a:graphicFrameLocks noGrp="1"/>
+          </p:cNvGraphicFramePr>
+          <p:nvPr>
+            <p:extLst>
+              <p:ext uri="{D42A27DB-BD31-4B8C-83A1-F6EECF244321}">
+                <p14:modId xmlns:p14="http://schemas.microsoft.com/office/powerpoint/2010/main" val="2176308583"/>
+              </p:ext>
+            </p:extLst>
+          </p:nvPr>
+        </p:nvGraphicFramePr>
+        <p:xfrm>
+          <a:off x="1364750" y="1664770"/>
+          <a:ext cx="6166207" cy="2595880"/>
+        </p:xfrm>
+        <a:graphic>
+          <a:graphicData uri="http://schemas.openxmlformats.org/drawingml/2006/table">
+            <a:tbl>
+              <a:tblPr firstRow="1" bandRow="1">
+                <a:tableStyleId>{5C22544A-7EE6-4342-B048-85BDC9FD1C3A}</a:tableStyleId>
+              </a:tblPr>
+              <a:tblGrid>
+                <a:gridCol w="2529155">
+                  <a:extLst>
+                    <a:ext uri="{9D8B030D-6E8A-4147-A177-3AD203B41FA5}">
+                      <a16:colId xmlns:a16="http://schemas.microsoft.com/office/drawing/2014/main" val="3973072498"/>
+                    </a:ext>
+                  </a:extLst>
+                </a:gridCol>
+                <a:gridCol w="2250041">
+                  <a:extLst>
+                    <a:ext uri="{9D8B030D-6E8A-4147-A177-3AD203B41FA5}">
+                      <a16:colId xmlns:a16="http://schemas.microsoft.com/office/drawing/2014/main" val="3219327690"/>
+                    </a:ext>
+                  </a:extLst>
+                </a:gridCol>
+                <a:gridCol w="1387011">
+                  <a:extLst>
+                    <a:ext uri="{9D8B030D-6E8A-4147-A177-3AD203B41FA5}">
+                      <a16:colId xmlns:a16="http://schemas.microsoft.com/office/drawing/2014/main" val="1864492444"/>
+                    </a:ext>
+                  </a:extLst>
+                </a:gridCol>
+              </a:tblGrid>
+              <a:tr h="370840">
+                <a:tc>
+                  <a:txBody>
+                    <a:bodyPr/>
+                    <a:lstStyle/>
+                    <a:p>
+                      <a:pPr>
+                        <a:buNone/>
+                      </a:pPr>
+                      <a:r>
+                        <a:rPr lang="de-DE">
+                          <a:effectLst/>
+                        </a:rPr>
+                        <a:t>Attack Type</a:t>
+                      </a:r>
+                    </a:p>
+                  </a:txBody>
+                  <a:tcPr marL="45720" marR="45720" marT="30480" marB="30480" anchor="ctr"/>
+                </a:tc>
+                <a:tc>
+                  <a:txBody>
+                    <a:bodyPr/>
+                    <a:lstStyle/>
+                    <a:p>
+                      <a:pPr>
+                        <a:buNone/>
+                      </a:pPr>
+                      <a:r>
+                        <a:rPr lang="de-DE">
+                          <a:effectLst/>
+                        </a:rPr>
+                        <a:t>Currently Detected?</a:t>
+                      </a:r>
+                    </a:p>
+                  </a:txBody>
+                  <a:tcPr marL="45720" marR="45720" marT="30480" marB="30480" anchor="ctr"/>
+                </a:tc>
+                <a:tc>
+                  <a:txBody>
+                    <a:bodyPr/>
+                    <a:lstStyle/>
+                    <a:p>
+                      <a:pPr>
+                        <a:buNone/>
+                      </a:pPr>
+                      <a:r>
+                        <a:rPr lang="de-DE">
+                          <a:effectLst/>
+                        </a:rPr>
+                        <a:t>Risk</a:t>
+                      </a:r>
+                    </a:p>
+                  </a:txBody>
+                  <a:tcPr marL="45720" marR="45720" marT="30480" marB="30480" anchor="ctr"/>
+                </a:tc>
+                <a:extLst>
+                  <a:ext uri="{0D108BD9-81ED-4DB2-BD59-A6C34878D82A}">
+                    <a16:rowId xmlns:a16="http://schemas.microsoft.com/office/drawing/2014/main" val="3789467604"/>
+                  </a:ext>
+                </a:extLst>
+              </a:tr>
+              <a:tr h="370840">
+                <a:tc>
+                  <a:txBody>
+                    <a:bodyPr/>
+                    <a:lstStyle/>
+                    <a:p>
+                      <a:pPr>
+                        <a:buNone/>
+                      </a:pPr>
+                      <a:r>
+                        <a:rPr lang="de-DE" b="1" dirty="0">
+                          <a:effectLst/>
+                        </a:rPr>
+                        <a:t>Phantom/</a:t>
+                      </a:r>
+                      <a:r>
+                        <a:rPr lang="de-DE" b="1" dirty="0" err="1">
+                          <a:effectLst/>
+                        </a:rPr>
+                        <a:t>hallucinated</a:t>
+                      </a:r>
+                      <a:r>
+                        <a:rPr lang="de-DE" b="1" dirty="0">
+                          <a:effectLst/>
+                        </a:rPr>
+                        <a:t> </a:t>
+                      </a:r>
+                      <a:r>
+                        <a:rPr lang="de-DE" b="1" dirty="0" err="1">
+                          <a:effectLst/>
+                        </a:rPr>
+                        <a:t>packages</a:t>
+                      </a:r>
+                      <a:endParaRPr lang="de-DE" dirty="0">
+                        <a:effectLst/>
+                      </a:endParaRPr>
+                    </a:p>
+                  </a:txBody>
+                  <a:tcPr marL="45720" marR="45720" marT="30480" marB="30480" anchor="ctr"/>
+                </a:tc>
+                <a:tc>
+                  <a:txBody>
+                    <a:bodyPr/>
+                    <a:lstStyle/>
+                    <a:p>
+                      <a:pPr>
+                        <a:buNone/>
+                      </a:pPr>
+                      <a:r>
+                        <a:rPr lang="de-DE">
+                          <a:effectLst/>
+                        </a:rPr>
+                        <a:t>Manual review only ❌</a:t>
+                      </a:r>
+                    </a:p>
+                  </a:txBody>
+                  <a:tcPr marL="45720" marR="45720" marT="30480" marB="30480" anchor="ctr"/>
+                </a:tc>
+                <a:tc>
+                  <a:txBody>
+                    <a:bodyPr/>
+                    <a:lstStyle/>
+                    <a:p>
+                      <a:pPr>
+                        <a:buNone/>
+                      </a:pPr>
+                      <a:r>
+                        <a:rPr lang="de-DE" b="1">
+                          <a:effectLst/>
+                        </a:rPr>
+                        <a:t>CRITICAL</a:t>
+                      </a:r>
+                      <a:endParaRPr lang="de-DE">
+                        <a:effectLst/>
+                      </a:endParaRPr>
+                    </a:p>
+                  </a:txBody>
+                  <a:tcPr marL="45720" marR="45720" marT="30480" marB="30480" anchor="ctr"/>
+                </a:tc>
+                <a:extLst>
+                  <a:ext uri="{0D108BD9-81ED-4DB2-BD59-A6C34878D82A}">
+                    <a16:rowId xmlns:a16="http://schemas.microsoft.com/office/drawing/2014/main" val="2219191530"/>
+                  </a:ext>
+                </a:extLst>
+              </a:tr>
+              <a:tr h="370840">
+                <a:tc>
+                  <a:txBody>
+                    <a:bodyPr/>
+                    <a:lstStyle/>
+                    <a:p>
+                      <a:pPr>
+                        <a:buNone/>
+                      </a:pPr>
+                      <a:r>
+                        <a:rPr lang="de-DE" b="1">
+                          <a:effectLst/>
+                        </a:rPr>
+                        <a:t>Dependency confusion</a:t>
+                      </a:r>
+                      <a:endParaRPr lang="de-DE">
+                        <a:effectLst/>
+                      </a:endParaRPr>
+                    </a:p>
+                  </a:txBody>
+                  <a:tcPr marL="45720" marR="45720" marT="30480" marB="30480" anchor="ctr"/>
+                </a:tc>
+                <a:tc>
+                  <a:txBody>
+                    <a:bodyPr/>
+                    <a:lstStyle/>
+                    <a:p>
+                      <a:pPr>
+                        <a:buNone/>
+                      </a:pPr>
+                      <a:r>
+                        <a:rPr lang="de-DE">
+                          <a:effectLst/>
+                        </a:rPr>
+                        <a:t>Not detected ❌</a:t>
+                      </a:r>
+                    </a:p>
+                  </a:txBody>
+                  <a:tcPr marL="45720" marR="45720" marT="30480" marB="30480" anchor="ctr"/>
+                </a:tc>
+                <a:tc>
+                  <a:txBody>
+                    <a:bodyPr/>
+                    <a:lstStyle/>
+                    <a:p>
+                      <a:pPr>
+                        <a:buNone/>
+                      </a:pPr>
+                      <a:r>
+                        <a:rPr lang="de-DE" b="1">
+                          <a:effectLst/>
+                        </a:rPr>
+                        <a:t>HIGH</a:t>
+                      </a:r>
+                      <a:endParaRPr lang="de-DE">
+                        <a:effectLst/>
+                      </a:endParaRPr>
+                    </a:p>
+                  </a:txBody>
+                  <a:tcPr marL="45720" marR="45720" marT="30480" marB="30480" anchor="ctr"/>
+                </a:tc>
+                <a:extLst>
+                  <a:ext uri="{0D108BD9-81ED-4DB2-BD59-A6C34878D82A}">
+                    <a16:rowId xmlns:a16="http://schemas.microsoft.com/office/drawing/2014/main" val="3994286507"/>
+                  </a:ext>
+                </a:extLst>
+              </a:tr>
+              <a:tr h="370840">
+                <a:tc>
+                  <a:txBody>
+                    <a:bodyPr/>
+                    <a:lstStyle/>
+                    <a:p>
+                      <a:pPr>
+                        <a:buNone/>
+                      </a:pPr>
+                      <a:r>
+                        <a:rPr lang="de-DE" b="1">
+                          <a:effectLst/>
+                        </a:rPr>
+                        <a:t>Compromised transitive deps</a:t>
+                      </a:r>
+                      <a:endParaRPr lang="de-DE">
+                        <a:effectLst/>
+                      </a:endParaRPr>
+                    </a:p>
+                  </a:txBody>
+                  <a:tcPr marL="45720" marR="45720" marT="30480" marB="30480" anchor="ctr"/>
+                </a:tc>
+                <a:tc>
+                  <a:txBody>
+                    <a:bodyPr/>
+                    <a:lstStyle/>
+                    <a:p>
+                      <a:pPr>
+                        <a:buNone/>
+                      </a:pPr>
+                      <a:r>
+                        <a:rPr lang="de-DE">
+                          <a:effectLst/>
+                        </a:rPr>
+                        <a:t>Partial at best ❌</a:t>
+                      </a:r>
+                    </a:p>
+                  </a:txBody>
+                  <a:tcPr marL="45720" marR="45720" marT="30480" marB="30480" anchor="ctr"/>
+                </a:tc>
+                <a:tc>
+                  <a:txBody>
+                    <a:bodyPr/>
+                    <a:lstStyle/>
+                    <a:p>
+                      <a:pPr>
+                        <a:buNone/>
+                      </a:pPr>
+                      <a:r>
+                        <a:rPr lang="de-DE" b="1">
+                          <a:effectLst/>
+                        </a:rPr>
+                        <a:t>HIGH</a:t>
+                      </a:r>
+                      <a:endParaRPr lang="de-DE">
+                        <a:effectLst/>
+                      </a:endParaRPr>
+                    </a:p>
+                  </a:txBody>
+                  <a:tcPr marL="45720" marR="45720" marT="30480" marB="30480" anchor="ctr"/>
+                </a:tc>
+                <a:extLst>
+                  <a:ext uri="{0D108BD9-81ED-4DB2-BD59-A6C34878D82A}">
+                    <a16:rowId xmlns:a16="http://schemas.microsoft.com/office/drawing/2014/main" val="4013705449"/>
+                  </a:ext>
+                </a:extLst>
+              </a:tr>
+              <a:tr h="370840">
+                <a:tc>
+                  <a:txBody>
+                    <a:bodyPr/>
+                    <a:lstStyle/>
+                    <a:p>
+                      <a:pPr>
+                        <a:buNone/>
+                      </a:pPr>
+                      <a:r>
+                        <a:rPr lang="de-DE" b="1">
+                          <a:effectLst/>
+                        </a:rPr>
+                        <a:t>Container image tampering</a:t>
+                      </a:r>
+                      <a:endParaRPr lang="de-DE">
+                        <a:effectLst/>
+                      </a:endParaRPr>
+                    </a:p>
+                  </a:txBody>
+                  <a:tcPr marL="45720" marR="45720" marT="30480" marB="30480" anchor="ctr"/>
+                </a:tc>
+                <a:tc>
+                  <a:txBody>
+                    <a:bodyPr/>
+                    <a:lstStyle/>
+                    <a:p>
+                      <a:pPr>
+                        <a:buNone/>
+                      </a:pPr>
+                      <a:r>
+                        <a:rPr lang="de-DE">
+                          <a:effectLst/>
+                        </a:rPr>
+                        <a:t>No verification ❌</a:t>
+                      </a:r>
+                    </a:p>
+                  </a:txBody>
+                  <a:tcPr marL="45720" marR="45720" marT="30480" marB="30480" anchor="ctr"/>
+                </a:tc>
+                <a:tc>
+                  <a:txBody>
+                    <a:bodyPr/>
+                    <a:lstStyle/>
+                    <a:p>
+                      <a:pPr>
+                        <a:buNone/>
+                      </a:pPr>
+                      <a:r>
+                        <a:rPr lang="de-DE" b="1">
+                          <a:effectLst/>
+                        </a:rPr>
+                        <a:t>HIGH</a:t>
+                      </a:r>
+                      <a:endParaRPr lang="de-DE">
+                        <a:effectLst/>
+                      </a:endParaRPr>
+                    </a:p>
+                  </a:txBody>
+                  <a:tcPr marL="45720" marR="45720" marT="30480" marB="30480" anchor="ctr"/>
+                </a:tc>
+                <a:extLst>
+                  <a:ext uri="{0D108BD9-81ED-4DB2-BD59-A6C34878D82A}">
+                    <a16:rowId xmlns:a16="http://schemas.microsoft.com/office/drawing/2014/main" val="3690844594"/>
+                  </a:ext>
+                </a:extLst>
+              </a:tr>
+              <a:tr h="370840">
+                <a:tc>
+                  <a:txBody>
+                    <a:bodyPr/>
+                    <a:lstStyle/>
+                    <a:p>
+                      <a:pPr>
+                        <a:buNone/>
+                      </a:pPr>
+                      <a:r>
+                        <a:rPr lang="de-DE" b="1">
+                          <a:effectLst/>
+                        </a:rPr>
+                        <a:t>Build artifact tampering</a:t>
+                      </a:r>
+                      <a:endParaRPr lang="de-DE">
+                        <a:effectLst/>
+                      </a:endParaRPr>
+                    </a:p>
+                  </a:txBody>
+                  <a:tcPr marL="45720" marR="45720" marT="30480" marB="30480" anchor="ctr"/>
+                </a:tc>
+                <a:tc>
+                  <a:txBody>
+                    <a:bodyPr/>
+                    <a:lstStyle/>
+                    <a:p>
+                      <a:pPr>
+                        <a:buNone/>
+                      </a:pPr>
+                      <a:r>
+                        <a:rPr lang="de-DE">
+                          <a:effectLst/>
+                        </a:rPr>
+                        <a:t>No signing/attestation ❌</a:t>
+                      </a:r>
+                    </a:p>
+                  </a:txBody>
+                  <a:tcPr marL="45720" marR="45720" marT="30480" marB="30480" anchor="ctr"/>
+                </a:tc>
+                <a:tc>
+                  <a:txBody>
+                    <a:bodyPr/>
+                    <a:lstStyle/>
+                    <a:p>
+                      <a:pPr>
+                        <a:buNone/>
+                      </a:pPr>
+                      <a:r>
+                        <a:rPr lang="de-DE" b="1">
+                          <a:effectLst/>
+                        </a:rPr>
+                        <a:t>HIGH</a:t>
+                      </a:r>
+                      <a:endParaRPr lang="de-DE">
+                        <a:effectLst/>
+                      </a:endParaRPr>
+                    </a:p>
+                  </a:txBody>
+                  <a:tcPr marL="45720" marR="45720" marT="30480" marB="30480" anchor="ctr"/>
+                </a:tc>
+                <a:extLst>
+                  <a:ext uri="{0D108BD9-81ED-4DB2-BD59-A6C34878D82A}">
+                    <a16:rowId xmlns:a16="http://schemas.microsoft.com/office/drawing/2014/main" val="1958485310"/>
+                  </a:ext>
+                </a:extLst>
+              </a:tr>
+              <a:tr h="370840">
+                <a:tc>
+                  <a:txBody>
+                    <a:bodyPr/>
+                    <a:lstStyle/>
+                    <a:p>
+                      <a:pPr>
+                        <a:buNone/>
+                      </a:pPr>
+                      <a:r>
+                        <a:rPr lang="de-DE" b="1">
+                          <a:effectLst/>
+                        </a:rPr>
+                        <a:t>Lockfile manipulation</a:t>
+                      </a:r>
+                      <a:endParaRPr lang="de-DE">
+                        <a:effectLst/>
+                      </a:endParaRPr>
+                    </a:p>
+                  </a:txBody>
+                  <a:tcPr marL="45720" marR="45720" marT="30480" marB="30480" anchor="ctr"/>
+                </a:tc>
+                <a:tc>
+                  <a:txBody>
+                    <a:bodyPr/>
+                    <a:lstStyle/>
+                    <a:p>
+                      <a:pPr>
+                        <a:buNone/>
+                      </a:pPr>
+                      <a:r>
+                        <a:rPr lang="de-DE">
+                          <a:effectLst/>
+                        </a:rPr>
+                        <a:t>No hash verification ❌</a:t>
+                      </a:r>
+                    </a:p>
+                  </a:txBody>
+                  <a:tcPr marL="45720" marR="45720" marT="30480" marB="30480" anchor="ctr"/>
+                </a:tc>
+                <a:tc>
+                  <a:txBody>
+                    <a:bodyPr/>
+                    <a:lstStyle/>
+                    <a:p>
+                      <a:pPr>
+                        <a:buNone/>
+                      </a:pPr>
+                      <a:r>
+                        <a:rPr lang="de-DE" b="1" dirty="0">
+                          <a:effectLst/>
+                        </a:rPr>
+                        <a:t>MEDIUM</a:t>
+                      </a:r>
+                      <a:endParaRPr lang="de-DE" dirty="0">
+                        <a:effectLst/>
+                      </a:endParaRPr>
+                    </a:p>
+                  </a:txBody>
+                  <a:tcPr marL="45720" marR="45720" marT="30480" marB="30480" anchor="ctr"/>
+                </a:tc>
+                <a:extLst>
+                  <a:ext uri="{0D108BD9-81ED-4DB2-BD59-A6C34878D82A}">
+                    <a16:rowId xmlns:a16="http://schemas.microsoft.com/office/drawing/2014/main" val="4230772824"/>
+                  </a:ext>
+                </a:extLst>
+              </a:tr>
+            </a:tbl>
+          </a:graphicData>
+        </a:graphic>
+      </p:graphicFrame>
     </p:spTree>
+    <p:extLst>
+      <p:ext uri="{BB962C8B-B14F-4D97-AF65-F5344CB8AC3E}">
+        <p14:creationId xmlns:p14="http://schemas.microsoft.com/office/powerpoint/2010/main" val="1773085015"/>
+      </p:ext>
+    </p:extLst>
   </p:cSld>
   <p:clrMapOvr>
     <a:masterClrMapping/>
@@ -11039,7 +11620,7 @@
               <a:buNone/>
             </a:pPr>
             <a:r>
-              <a:t>The Bottom Line</a:t>
+              <a:t>The Paradox</a:t>
             </a:r>
           </a:p>
         </p:txBody>
@@ -11063,15 +11644,15 @@
               <a:buNone/>
             </a:pPr>
             <a:r>
-              <a:t>The joke goes that the “S” in vibe coding stands for security. It’s funny because, too often, it’s true.</a:t>
-            </a:r>
-          </a:p>
-          <a:p>
-            <a:pPr marL="0" lvl="0" indent="0">
-              <a:buNone/>
-            </a:pPr>
-            <a:r>
-              <a:t>The gap isn’t only in the tooling anymore. It’s in the habits. Build fast, but build like someone’s trying to break in, because they are.</a:t>
+              <a:t>AI is both the problem and part of the solution. It introduces vulnerabilities faster than humans, but AI-powered scanners can also review code at machine speed and catch bugs people miss.</a:t>
+            </a:r>
+          </a:p>
+          <a:p>
+            <a:pPr marL="0" lvl="0" indent="0">
+              <a:buNone/>
+            </a:pPr>
+            <a:r>
+              <a:t>The future of secure vibe coding is not human or AI. It’s both layers working together.</a:t>
             </a:r>
           </a:p>
         </p:txBody>
@@ -11111,12 +11692,7 @@
             <p:ph type="title"/>
           </p:nvPr>
         </p:nvSpPr>
-        <p:spPr>
-          <a:xfrm>
-            <a:off x="722313" y="3305176"/>
-            <a:ext cx="7772400" cy="1021556"/>
-          </a:xfrm>
-        </p:spPr>
+        <p:spPr/>
         <p:txBody>
           <a:bodyPr/>
           <a:lstStyle/>
@@ -11125,7 +11701,39 @@
               <a:buNone/>
             </a:pPr>
             <a:r>
-              <a:t>Chapter 6: Legal and IP</a:t>
+              <a:t>The Bottom Line</a:t>
+            </a:r>
+          </a:p>
+        </p:txBody>
+      </p:sp>
+      <p:sp>
+        <p:nvSpPr>
+          <p:cNvPr id="3" name="Content Placeholder 2"/>
+          <p:cNvSpPr>
+            <a:spLocks noGrp="1"/>
+          </p:cNvSpPr>
+          <p:nvPr>
+            <p:ph idx="1"/>
+          </p:nvPr>
+        </p:nvSpPr>
+        <p:spPr/>
+        <p:txBody>
+          <a:bodyPr/>
+          <a:lstStyle/>
+          <a:p>
+            <a:pPr marL="0" lvl="0" indent="0">
+              <a:buNone/>
+            </a:pPr>
+            <a:r>
+              <a:t>The joke goes that the “S” in vibe coding stands for security. It’s funny because, too often, it’s true.</a:t>
+            </a:r>
+          </a:p>
+          <a:p>
+            <a:pPr marL="0" lvl="0" indent="0">
+              <a:buNone/>
+            </a:pPr>
+            <a:r>
+              <a:t>The gap isn’t only in the tooling anymore. It’s in the habits. Build fast, but build like someone’s trying to break in, because they are.</a:t>
             </a:r>
           </a:p>
         </p:txBody>
@@ -11157,15 +11765,20 @@
       </p:grpSpPr>
       <p:sp>
         <p:nvSpPr>
-          <p:cNvPr id="3" name="Content Placeholder 2"/>
-          <p:cNvSpPr>
-            <a:spLocks noGrp="1"/>
-          </p:cNvSpPr>
-          <p:nvPr>
-            <p:ph idx="1"/>
-          </p:nvPr>
-        </p:nvSpPr>
-        <p:spPr/>
+          <p:cNvPr id="2" name="Title 1"/>
+          <p:cNvSpPr>
+            <a:spLocks noGrp="1"/>
+          </p:cNvSpPr>
+          <p:nvPr>
+            <p:ph type="title"/>
+          </p:nvPr>
+        </p:nvSpPr>
+        <p:spPr>
+          <a:xfrm>
+            <a:off x="722313" y="3305176"/>
+            <a:ext cx="7772400" cy="1021556"/>
+          </a:xfrm>
+        </p:spPr>
         <p:txBody>
           <a:bodyPr/>
           <a:lstStyle/>
@@ -11174,7 +11787,7 @@
               <a:buNone/>
             </a:pPr>
             <a:r>
-              <a:t>AI writes the code. But who owns it? Who is liable when it breaks? And what happens when the AI copies someone else’s work? These questions do not have clean answers yet, but ignoring them is not an option.</a:t>
+              <a:t>Chapter 6: Legal and IP</a:t>
             </a:r>
           </a:p>
         </p:txBody>
@@ -11206,12 +11819,12 @@
       </p:grpSpPr>
       <p:sp>
         <p:nvSpPr>
-          <p:cNvPr id="2" name="Title 1"/>
-          <p:cNvSpPr>
-            <a:spLocks noGrp="1"/>
-          </p:cNvSpPr>
-          <p:nvPr>
-            <p:ph type="title"/>
+          <p:cNvPr id="3" name="Content Placeholder 2"/>
+          <p:cNvSpPr>
+            <a:spLocks noGrp="1"/>
+          </p:cNvSpPr>
+          <p:nvPr>
+            <p:ph idx="1"/>
           </p:nvPr>
         </p:nvSpPr>
         <p:spPr/>
@@ -11223,75 +11836,7 @@
               <a:buNone/>
             </a:pPr>
             <a:r>
-              <a:t>Who Owns AI-Generated Code?</a:t>
-            </a:r>
-          </a:p>
-        </p:txBody>
-      </p:sp>
-      <p:sp>
-        <p:nvSpPr>
-          <p:cNvPr id="3" name="Content Placeholder 2"/>
-          <p:cNvSpPr>
-            <a:spLocks noGrp="1"/>
-          </p:cNvSpPr>
-          <p:nvPr>
-            <p:ph idx="1"/>
-          </p:nvPr>
-        </p:nvSpPr>
-        <p:spPr/>
-        <p:txBody>
-          <a:bodyPr>
-            <a:normAutofit lnSpcReduction="10000"/>
-          </a:bodyPr>
-          <a:lstStyle/>
-          <a:p>
-            <a:pPr marL="0" lvl="0" indent="0">
-              <a:buNone/>
-            </a:pPr>
-            <a:r>
-              <a:t>Major AI providers such as OpenAI, Anthropic, and Google contractually assign output ownership to users. In that narrow sense, you prompt it and you own it.</a:t>
-            </a:r>
-          </a:p>
-          <a:p>
-            <a:pPr marL="0" lvl="0" indent="0">
-              <a:buNone/>
-            </a:pPr>
-            <a:r>
-              <a:t>But copyright law is messier. Courts in the United States and Europe have reinforced the view that purely AI-generated content cannot itself be copyrighted. If no human made meaningful creative contributions, there may be nothing to protect.</a:t>
-            </a:r>
-          </a:p>
-          <a:p>
-            <a:pPr marL="0" lvl="0" indent="0">
-              <a:buNone/>
-            </a:pPr>
-            <a:r>
-              <a:t>The practical result is awkward:</a:t>
-            </a:r>
-          </a:p>
-          <a:p>
-            <a:pPr lvl="0"/>
-            <a:r>
-              <a:t>You may own the output contractually because the provider does not claim it</a:t>
-            </a:r>
-          </a:p>
-          <a:p>
-            <a:pPr lvl="0"/>
-            <a:r>
-              <a:t>You may still be unable to enforce copyright over purely AI-generated portions</a:t>
-            </a:r>
-          </a:p>
-          <a:p>
-            <a:pPr lvl="0"/>
-            <a:r>
-              <a:t>Copyright protection is stronger where you add substantial human contribution through editing, integration, or architecture</a:t>
-            </a:r>
-          </a:p>
-          <a:p>
-            <a:pPr marL="0" lvl="0" indent="0">
-              <a:buNone/>
-            </a:pPr>
-            <a:r>
-              <a:t>Document your human contributions carefully.</a:t>
+              <a:t>AI writes the code. But who owns it? Who is liable when it breaks? And what happens when the AI copies someone else’s work? These questions do not have clean answers yet, but ignoring them is not an option.</a:t>
             </a:r>
           </a:p>
         </p:txBody>
@@ -11340,7 +11885,7 @@
               <a:buNone/>
             </a:pPr>
             <a:r>
-              <a:t>The GPL Problem</a:t>
+              <a:t>Who Owns AI-Generated Code?</a:t>
             </a:r>
           </a:p>
         </p:txBody>
@@ -11357,52 +11902,58 @@
         </p:nvSpPr>
         <p:spPr/>
         <p:txBody>
-          <a:bodyPr/>
+          <a:bodyPr>
+            <a:normAutofit lnSpcReduction="10000"/>
+          </a:bodyPr>
           <a:lstStyle/>
           <a:p>
             <a:pPr marL="0" lvl="0" indent="0">
               <a:buNone/>
             </a:pPr>
             <a:r>
-              <a:t>One of the biggest active legal concerns is whether AI coding tools can reproduce licensed code without preserving the required notices or attribution.</a:t>
-            </a:r>
-          </a:p>
-          <a:p>
-            <a:pPr marL="0" lvl="0" indent="0">
-              <a:buNone/>
-            </a:pPr>
-            <a:r>
-              <a:t>The risk to organizations is straightforward: if an AI tool reproduces GPL-licensed code and you ship it in a proprietary product, you may be violating that license. The provider’s terms of service do not shield you from third-party claims.</a:t>
-            </a:r>
-          </a:p>
-          <a:p>
-            <a:pPr marL="0" lvl="0" indent="0">
-              <a:spcBef>
-                <a:spcPts val="3000"/>
-              </a:spcBef>
-              <a:buNone/>
-            </a:pPr>
-            <a:r>
-              <a:rPr b="1"/>
-              <a:t>Practical Response</a:t>
-            </a:r>
-          </a:p>
-          <a:p>
-            <a:pPr lvl="0"/>
-            <a:r>
-              <a:t>Run Software Composition Analysis tools on AI-generated code</a:t>
-            </a:r>
-          </a:p>
-          <a:p>
-            <a:pPr lvl="0"/>
-            <a:r>
-              <a:t>Enable duplicate detection where available</a:t>
-            </a:r>
-          </a:p>
-          <a:p>
-            <a:pPr lvl="0"/>
-            <a:r>
-              <a:t>Treat AI output like code from an unknown contributor and review it accordingly</a:t>
+              <a:t>Major AI providers such as OpenAI, Anthropic, and Google contractually assign output ownership to users. In that narrow sense, you prompt it and you own it.</a:t>
+            </a:r>
+          </a:p>
+          <a:p>
+            <a:pPr marL="0" lvl="0" indent="0">
+              <a:buNone/>
+            </a:pPr>
+            <a:r>
+              <a:t>But copyright law is messier. Courts in the United States and Europe have reinforced the view that purely AI-generated content cannot itself be copyrighted. If no human made meaningful creative contributions, there may be nothing to protect.</a:t>
+            </a:r>
+          </a:p>
+          <a:p>
+            <a:pPr marL="0" lvl="0" indent="0">
+              <a:buNone/>
+            </a:pPr>
+            <a:r>
+              <a:t>The practical result is awkward:</a:t>
+            </a:r>
+          </a:p>
+          <a:p>
+            <a:pPr lvl="0"/>
+            <a:r>
+              <a:t>You may own the output contractually because the provider does not claim it</a:t>
+            </a:r>
+          </a:p>
+          <a:p>
+            <a:pPr lvl="0"/>
+            <a:r>
+              <a:t>You may still be unable to enforce copyright over purely AI-generated portions</a:t>
+            </a:r>
+          </a:p>
+          <a:p>
+            <a:pPr lvl="0"/>
+            <a:r>
+              <a:t>Copyright protection is stronger where you add substantial human contribution through editing, integration, or architecture</a:t>
+            </a:r>
+          </a:p>
+          <a:p>
+            <a:pPr marL="0" lvl="0" indent="0">
+              <a:buNone/>
+            </a:pPr>
+            <a:r>
+              <a:t>Document your human contributions carefully.</a:t>
             </a:r>
           </a:p>
         </p:txBody>
@@ -11451,7 +12002,7 @@
               <a:buNone/>
             </a:pPr>
             <a:r>
-              <a:t>Liability: Who’s Responsible?</a:t>
+              <a:t>The GPL Problem</a:t>
             </a:r>
           </a:p>
         </p:txBody>
@@ -11468,24 +12019,22 @@
         </p:nvSpPr>
         <p:spPr/>
         <p:txBody>
-          <a:bodyPr>
-            <a:normAutofit lnSpcReduction="10000"/>
-          </a:bodyPr>
+          <a:bodyPr/>
           <a:lstStyle/>
           <a:p>
             <a:pPr marL="0" lvl="0" indent="0">
               <a:buNone/>
             </a:pPr>
             <a:r>
-              <a:t>No court has definitively resolved all liability questions around AI-generated code, but the practical trajectory is clear: the developer or organization that ships the code remains responsible for it.</a:t>
-            </a:r>
-          </a:p>
-          <a:p>
-            <a:pPr marL="0" lvl="0" indent="0">
-              <a:buNone/>
-            </a:pPr>
-            <a:r>
-              <a:t>“The AI suggested it” is not a legal defense, just as “I copied it from Stack Overflow” never was.</a:t>
+              <a:t>One of the biggest active legal concerns is whether AI coding tools can reproduce licensed code without preserving the required notices or attribution.</a:t>
+            </a:r>
+          </a:p>
+          <a:p>
+            <a:pPr marL="0" lvl="0" indent="0">
+              <a:buNone/>
+            </a:pPr>
+            <a:r>
+              <a:t>The risk to organizations is straightforward: if an AI tool reproduces GPL-licensed code and you ship it in a proprietary product, you may be violating that license. The provider’s terms of service do not shield you from third-party claims.</a:t>
             </a:r>
           </a:p>
           <a:p>
@@ -11497,33 +12046,25 @@
             </a:pPr>
             <a:r>
               <a:rPr b="1"/>
-              <a:t>Emerging Developments</a:t>
-            </a:r>
-          </a:p>
-          <a:p>
-            <a:pPr lvl="0"/>
-            <a:r>
-              <a:t>Some cyber insurance policies exclude damages from unverified AI output</a:t>
-            </a:r>
-          </a:p>
-          <a:p>
-            <a:pPr lvl="0"/>
-            <a:r>
-              <a:t>Legislatures are creating new rights of action for AI-related harms</a:t>
-            </a:r>
-          </a:p>
-          <a:p>
-            <a:pPr lvl="0"/>
-            <a:r>
-              <a:t>Conversations with AI platforms may be discoverable in litigation</a:t>
-            </a:r>
-          </a:p>
-          <a:p>
-            <a:pPr marL="0" lvl="0" indent="0">
-              <a:buNone/>
-            </a:pPr>
-            <a:r>
-              <a:t>Anything you paste into an AI system could later matter in court.</a:t>
+              <a:t>Practical Response</a:t>
+            </a:r>
+          </a:p>
+          <a:p>
+            <a:pPr lvl="0"/>
+            <a:r>
+              <a:t>Run Software Composition Analysis tools on AI-generated code</a:t>
+            </a:r>
+          </a:p>
+          <a:p>
+            <a:pPr lvl="0"/>
+            <a:r>
+              <a:t>Enable duplicate detection where available</a:t>
+            </a:r>
+          </a:p>
+          <a:p>
+            <a:pPr lvl="0"/>
+            <a:r>
+              <a:t>Treat AI output like code from an unknown contributor and review it accordingly</a:t>
             </a:r>
           </a:p>
         </p:txBody>
@@ -11619,7 +12160,7 @@
         </p:nvGraphicFramePr>
         <p:xfrm>
           <a:off x="3568700" y="203200"/>
-          <a:ext cx="5105400" cy="4381500"/>
+          <a:ext cx="5105400" cy="2720340"/>
         </p:xfrm>
         <a:graphic>
           <a:graphicData uri="http://schemas.openxmlformats.org/drawingml/2006/table">
@@ -11958,7 +12499,7 @@
               <a:buNone/>
             </a:pPr>
             <a:r>
-              <a:t>The EU AI Act</a:t>
+              <a:t>Liability: Who’s Responsible?</a:t>
             </a:r>
           </a:p>
         </p:txBody>
@@ -11975,54 +12516,62 @@
         </p:nvSpPr>
         <p:spPr/>
         <p:txBody>
-          <a:bodyPr/>
+          <a:bodyPr>
+            <a:normAutofit lnSpcReduction="10000"/>
+          </a:bodyPr>
           <a:lstStyle/>
           <a:p>
             <a:pPr marL="0" lvl="0" indent="0">
               <a:buNone/>
             </a:pPr>
             <a:r>
-              <a:t>AI coding tools built on general-purpose AI models fall under the GPAI provisions of the EU AI Act.</a:t>
-            </a:r>
-          </a:p>
-          <a:p>
-            <a:pPr marL="0" lvl="0" indent="0">
-              <a:buNone/>
-            </a:pPr>
-            <a:r>
-              <a:t>Key obligations for providers include:</a:t>
-            </a:r>
-          </a:p>
-          <a:p>
-            <a:pPr lvl="0"/>
-            <a:r>
-              <a:t>Maintaining detailed technical documentation</a:t>
-            </a:r>
-          </a:p>
-          <a:p>
-            <a:pPr lvl="0"/>
-            <a:r>
-              <a:t>Publishing summaries of copyrighted training data used</a:t>
-            </a:r>
-          </a:p>
-          <a:p>
-            <a:pPr lvl="0"/>
-            <a:r>
-              <a:t>Demonstrating copyright compliance in training data sourcing</a:t>
-            </a:r>
-          </a:p>
-          <a:p>
-            <a:pPr lvl="0"/>
-            <a:r>
-              <a:t>Submitting documentation to regulators on request</a:t>
-            </a:r>
-          </a:p>
-          <a:p>
-            <a:pPr marL="0" lvl="0" indent="0">
-              <a:buNone/>
-            </a:pPr>
-            <a:r>
-              <a:t>For organizations using these tools, the burden is practical rather than theoretical: know which tools are compliant, what data you send to them, and whether your use case triggers additional obligations.</a:t>
+              <a:t>No court has definitively resolved all liability questions around AI-generated code, but the practical trajectory is clear: the developer or organization that ships the code remains responsible for it.</a:t>
+            </a:r>
+          </a:p>
+          <a:p>
+            <a:pPr marL="0" lvl="0" indent="0">
+              <a:buNone/>
+            </a:pPr>
+            <a:r>
+              <a:t>“The AI suggested it” is not a legal defense, just as “I copied it from Stack Overflow” never was.</a:t>
+            </a:r>
+          </a:p>
+          <a:p>
+            <a:pPr marL="0" lvl="0" indent="0">
+              <a:spcBef>
+                <a:spcPts val="3000"/>
+              </a:spcBef>
+              <a:buNone/>
+            </a:pPr>
+            <a:r>
+              <a:rPr b="1"/>
+              <a:t>Emerging Developments</a:t>
+            </a:r>
+          </a:p>
+          <a:p>
+            <a:pPr lvl="0"/>
+            <a:r>
+              <a:t>Some cyber insurance policies exclude damages from unverified AI output</a:t>
+            </a:r>
+          </a:p>
+          <a:p>
+            <a:pPr lvl="0"/>
+            <a:r>
+              <a:t>Legislatures are creating new rights of action for AI-related harms</a:t>
+            </a:r>
+          </a:p>
+          <a:p>
+            <a:pPr lvl="0"/>
+            <a:r>
+              <a:t>Conversations with AI platforms may be discoverable in litigation</a:t>
+            </a:r>
+          </a:p>
+          <a:p>
+            <a:pPr marL="0" lvl="0" indent="0">
+              <a:buNone/>
+            </a:pPr>
+            <a:r>
+              <a:t>Anything you paste into an AI system could later matter in court.</a:t>
             </a:r>
           </a:p>
         </p:txBody>
@@ -12071,7 +12620,7 @@
               <a:buNone/>
             </a:pPr>
             <a:r>
-              <a:t>Audit Trails Are Coming</a:t>
+              <a:t>The EU AI Act</a:t>
             </a:r>
           </a:p>
         </p:txBody>
@@ -12095,33 +12644,47 @@
               <a:buNone/>
             </a:pPr>
             <a:r>
-              <a:t>The direction is clear: organizations will increasingly need to prove what was AI-generated and what was not.</a:t>
-            </a:r>
-          </a:p>
-          <a:p>
-            <a:pPr marL="0" lvl="0" indent="0">
-              <a:buNone/>
-            </a:pPr>
-            <a:r>
-              <a:t>That means:</a:t>
-            </a:r>
-          </a:p>
-          <a:p>
-            <a:pPr lvl="0"/>
-            <a:r>
-              <a:t>Tagging AI-generated code in version control</a:t>
-            </a:r>
-          </a:p>
-          <a:p>
-            <a:pPr lvl="0"/>
-            <a:r>
-              <a:t>Retaining prompt and response logs for high-risk work</a:t>
-            </a:r>
-          </a:p>
-          <a:p>
-            <a:pPr lvl="0"/>
-            <a:r>
-              <a:t>Documenting human modifications that create authorship and accountability</a:t>
+              <a:t>AI coding tools built on general-purpose AI models fall under the GPAI provisions of the EU AI Act.</a:t>
+            </a:r>
+          </a:p>
+          <a:p>
+            <a:pPr marL="0" lvl="0" indent="0">
+              <a:buNone/>
+            </a:pPr>
+            <a:r>
+              <a:t>Key obligations for providers include:</a:t>
+            </a:r>
+          </a:p>
+          <a:p>
+            <a:pPr lvl="0"/>
+            <a:r>
+              <a:t>Maintaining detailed technical documentation</a:t>
+            </a:r>
+          </a:p>
+          <a:p>
+            <a:pPr lvl="0"/>
+            <a:r>
+              <a:t>Publishing summaries of copyrighted training data used</a:t>
+            </a:r>
+          </a:p>
+          <a:p>
+            <a:pPr lvl="0"/>
+            <a:r>
+              <a:t>Demonstrating copyright compliance in training data sourcing</a:t>
+            </a:r>
+          </a:p>
+          <a:p>
+            <a:pPr lvl="0"/>
+            <a:r>
+              <a:t>Submitting documentation to regulators on request</a:t>
+            </a:r>
+          </a:p>
+          <a:p>
+            <a:pPr marL="0" lvl="0" indent="0">
+              <a:buNone/>
+            </a:pPr>
+            <a:r>
+              <a:t>For organizations using these tools, the burden is practical rather than theoretical: know which tools are compliant, what data you send to them, and whether your use case triggers additional obligations.</a:t>
             </a:r>
           </a:p>
         </p:txBody>
@@ -12170,7 +12733,7 @@
               <a:buNone/>
             </a:pPr>
             <a:r>
-              <a:t>Practical Checklist</a:t>
+              <a:t>Audit Trails Are Coming</a:t>
             </a:r>
           </a:p>
         </p:txBody>
@@ -12187,80 +12750,40 @@
         </p:nvSpPr>
         <p:spPr/>
         <p:txBody>
-          <a:bodyPr>
-            <a:normAutofit lnSpcReduction="10000"/>
-          </a:bodyPr>
+          <a:bodyPr/>
           <a:lstStyle/>
           <a:p>
-            <a:pPr marL="342900" lvl="0" indent="-342900">
-              <a:buAutoNum type="arabicPeriod"/>
-            </a:pPr>
-            <a:r>
-              <a:t>Use enterprise tiers of AI tools when you need indemnification and opt-outs.</a:t>
-            </a:r>
-          </a:p>
-          <a:p>
-            <a:pPr marL="342900" lvl="0" indent="-342900">
-              <a:buAutoNum type="arabicPeriod"/>
-            </a:pPr>
-            <a:r>
-              <a:t>Don’t paste secrets, PII, or proprietary algorithms into prompts.</a:t>
-            </a:r>
-          </a:p>
-          <a:p>
-            <a:pPr marL="342900" lvl="0" indent="-342900">
-              <a:buAutoNum type="arabicPeriod"/>
-            </a:pPr>
-            <a:r>
-              <a:t>Run license compliance scanning in CI/CD.</a:t>
-            </a:r>
-          </a:p>
-          <a:p>
-            <a:pPr marL="342900" lvl="0" indent="-342900">
-              <a:buAutoNum type="arabicPeriod"/>
-            </a:pPr>
-            <a:r>
-              <a:t>Tag AI-generated code in version control with provenance metadata.</a:t>
-            </a:r>
-          </a:p>
-          <a:p>
-            <a:pPr marL="342900" lvl="0" indent="-342900">
-              <a:buAutoNum type="arabicPeriod"/>
-            </a:pPr>
-            <a:r>
-              <a:t>Require human review for all AI-generated code before merge.</a:t>
-            </a:r>
-          </a:p>
-          <a:p>
-            <a:pPr marL="342900" lvl="0" indent="-342900">
-              <a:buAutoNum type="arabicPeriod"/>
-            </a:pPr>
-            <a:r>
-              <a:t>Review cyber insurance for AI-code exclusions.</a:t>
-            </a:r>
-          </a:p>
-          <a:p>
-            <a:pPr marL="342900" lvl="0" indent="-342900">
-              <a:buAutoNum type="arabicPeriod"/>
-            </a:pPr>
-            <a:r>
-              <a:t>Document human modifications to establish copyriht.</a:t>
-            </a:r>
-          </a:p>
-          <a:p>
-            <a:pPr marL="342900" lvl="0" indent="-342900">
-              <a:buAutoNum type="arabicPeriod"/>
-            </a:pPr>
-            <a:r>
-              <a:t>Create an AI coding policy covering approved tools, data classification, and review requirements.</a:t>
-            </a:r>
-          </a:p>
-          <a:p>
-            <a:pPr marL="0" lvl="0" indent="0">
-              <a:buNone/>
-            </a:pPr>
-            <a:r>
-              <a:t>The legal landscape is evolving quickly. What is settled is that you are responsible for the code you ship. Much of the rest is still moving.</a:t>
+            <a:pPr marL="0" lvl="0" indent="0">
+              <a:buNone/>
+            </a:pPr>
+            <a:r>
+              <a:t>The direction is clear: organizations will increasingly need to prove what was AI-generated and what was not.</a:t>
+            </a:r>
+          </a:p>
+          <a:p>
+            <a:pPr marL="0" lvl="0" indent="0">
+              <a:buNone/>
+            </a:pPr>
+            <a:r>
+              <a:t>That means:</a:t>
+            </a:r>
+          </a:p>
+          <a:p>
+            <a:pPr lvl="0"/>
+            <a:r>
+              <a:t>Tagging AI-generated code in version control</a:t>
+            </a:r>
+          </a:p>
+          <a:p>
+            <a:pPr lvl="0"/>
+            <a:r>
+              <a:t>Retaining prompt and response logs for high-risk work</a:t>
+            </a:r>
+          </a:p>
+          <a:p>
+            <a:pPr lvl="0"/>
+            <a:r>
+              <a:t>Documenting human modifications that create authorship and accountability</a:t>
             </a:r>
           </a:p>
         </p:txBody>
@@ -12300,12 +12823,7 @@
             <p:ph type="title"/>
           </p:nvPr>
         </p:nvSpPr>
-        <p:spPr>
-          <a:xfrm>
-            <a:off x="722313" y="3305176"/>
-            <a:ext cx="7772400" cy="1021556"/>
-          </a:xfrm>
-        </p:spPr>
+        <p:spPr/>
         <p:txBody>
           <a:bodyPr/>
           <a:lstStyle/>
@@ -12314,7 +12832,97 @@
               <a:buNone/>
             </a:pPr>
             <a:r>
-              <a:t>Chapter 7: Team and Organizational Impact</a:t>
+              <a:t>Practical Checklist</a:t>
+            </a:r>
+          </a:p>
+        </p:txBody>
+      </p:sp>
+      <p:sp>
+        <p:nvSpPr>
+          <p:cNvPr id="3" name="Content Placeholder 2"/>
+          <p:cNvSpPr>
+            <a:spLocks noGrp="1"/>
+          </p:cNvSpPr>
+          <p:nvPr>
+            <p:ph idx="1"/>
+          </p:nvPr>
+        </p:nvSpPr>
+        <p:spPr/>
+        <p:txBody>
+          <a:bodyPr>
+            <a:normAutofit lnSpcReduction="10000"/>
+          </a:bodyPr>
+          <a:lstStyle/>
+          <a:p>
+            <a:pPr marL="342900" lvl="0" indent="-342900">
+              <a:buAutoNum type="arabicPeriod"/>
+            </a:pPr>
+            <a:r>
+              <a:t>Use enterprise tiers of AI tools when you need indemnification and opt-outs.</a:t>
+            </a:r>
+          </a:p>
+          <a:p>
+            <a:pPr marL="342900" lvl="0" indent="-342900">
+              <a:buAutoNum type="arabicPeriod"/>
+            </a:pPr>
+            <a:r>
+              <a:t>Don’t paste secrets, PII, or proprietary algorithms into prompts.</a:t>
+            </a:r>
+          </a:p>
+          <a:p>
+            <a:pPr marL="342900" lvl="0" indent="-342900">
+              <a:buAutoNum type="arabicPeriod"/>
+            </a:pPr>
+            <a:r>
+              <a:t>Run license compliance scanning in CI/CD.</a:t>
+            </a:r>
+          </a:p>
+          <a:p>
+            <a:pPr marL="342900" lvl="0" indent="-342900">
+              <a:buAutoNum type="arabicPeriod"/>
+            </a:pPr>
+            <a:r>
+              <a:t>Tag AI-generated code in version control with provenance metadata.</a:t>
+            </a:r>
+          </a:p>
+          <a:p>
+            <a:pPr marL="342900" lvl="0" indent="-342900">
+              <a:buAutoNum type="arabicPeriod"/>
+            </a:pPr>
+            <a:r>
+              <a:t>Require human review for all AI-generated code before merge.</a:t>
+            </a:r>
+          </a:p>
+          <a:p>
+            <a:pPr marL="342900" lvl="0" indent="-342900">
+              <a:buAutoNum type="arabicPeriod"/>
+            </a:pPr>
+            <a:r>
+              <a:t>Review cyber insurance for AI-code exclusions.</a:t>
+            </a:r>
+          </a:p>
+          <a:p>
+            <a:pPr marL="342900" lvl="0" indent="-342900">
+              <a:buAutoNum type="arabicPeriod"/>
+            </a:pPr>
+            <a:r>
+              <a:t>Document human modifications to establish copyriht.</a:t>
+            </a:r>
+          </a:p>
+          <a:p>
+            <a:pPr marL="342900" lvl="0" indent="-342900">
+              <a:buAutoNum type="arabicPeriod"/>
+            </a:pPr>
+            <a:r>
+              <a:t>Create an AI coding policy covering approved tools, data classification, and review requirements.</a:t>
+            </a:r>
+          </a:p>
+          <a:p>
+            <a:pPr marL="0" lvl="0" indent="0">
+              <a:buNone/>
+            </a:pPr>
+            <a:r>
+              <a:t>The legal landscape is evolving quickly. What is settled is that you are responsible for the code you ship. Much of the rest is still moving.</a:t>
             </a:r>
           </a:p>
         </p:txBody>
@@ -12346,15 +12954,20 @@
       </p:grpSpPr>
       <p:sp>
         <p:nvSpPr>
-          <p:cNvPr id="3" name="Content Placeholder 2"/>
-          <p:cNvSpPr>
-            <a:spLocks noGrp="1"/>
-          </p:cNvSpPr>
-          <p:nvPr>
-            <p:ph idx="1"/>
-          </p:nvPr>
-        </p:nvSpPr>
-        <p:spPr/>
+          <p:cNvPr id="2" name="Title 1"/>
+          <p:cNvSpPr>
+            <a:spLocks noGrp="1"/>
+          </p:cNvSpPr>
+          <p:nvPr>
+            <p:ph type="title"/>
+          </p:nvPr>
+        </p:nvSpPr>
+        <p:spPr>
+          <a:xfrm>
+            <a:off x="722313" y="3305176"/>
+            <a:ext cx="7772400" cy="1021556"/>
+          </a:xfrm>
+        </p:spPr>
         <p:txBody>
           <a:bodyPr/>
           <a:lstStyle/>
@@ -12363,7 +12976,7 @@
               <a:buNone/>
             </a:pPr>
             <a:r>
-              <a:t>Vibe coding doesn’t just change how individuals write code. It reshapes teams, roles, hiring, and the structure of how organizations build software.</a:t>
+              <a:t>Chapter 7: Team and Organizational Impact</a:t>
             </a:r>
           </a:p>
         </p:txBody>
@@ -12395,12 +13008,12 @@
       </p:grpSpPr>
       <p:sp>
         <p:nvSpPr>
-          <p:cNvPr id="2" name="Title 1"/>
-          <p:cNvSpPr>
-            <a:spLocks noGrp="1"/>
-          </p:cNvSpPr>
-          <p:nvPr>
-            <p:ph type="title"/>
+          <p:cNvPr id="3" name="Content Placeholder 2"/>
+          <p:cNvSpPr>
+            <a:spLocks noGrp="1"/>
+          </p:cNvSpPr>
+          <p:nvPr>
+            <p:ph idx="1"/>
           </p:nvPr>
         </p:nvSpPr>
         <p:spPr/>
@@ -12412,73 +13025,7 @@
               <a:buNone/>
             </a:pPr>
             <a:r>
-              <a:t>Fewer Developers, Higher Seniority</a:t>
-            </a:r>
-          </a:p>
-        </p:txBody>
-      </p:sp>
-      <p:sp>
-        <p:nvSpPr>
-          <p:cNvPr id="3" name="Content Placeholder 2"/>
-          <p:cNvSpPr>
-            <a:spLocks noGrp="1"/>
-          </p:cNvSpPr>
-          <p:nvPr>
-            <p:ph idx="1"/>
-          </p:nvPr>
-        </p:nvSpPr>
-        <p:spPr/>
-        <p:txBody>
-          <a:bodyPr>
-            <a:normAutofit lnSpcReduction="10000"/>
-          </a:bodyPr>
-          <a:lstStyle/>
-          <a:p>
-            <a:pPr marL="0" lvl="0" indent="0">
-              <a:buNone/>
-            </a:pPr>
-            <a:r>
-              <a:t>One immediate effect is that small teams can do work that once required much larger ones. This does not mean organizations need less talent — it means they need different talent.</a:t>
-            </a:r>
-          </a:p>
-          <a:p>
-            <a:pPr marL="0" lvl="0" indent="0">
-              <a:buNone/>
-            </a:pPr>
-            <a:r>
-              <a:t>When AI writes the code, the bottleneck shifts from implementation to judgment. Teams need people who can:</a:t>
-            </a:r>
-          </a:p>
-          <a:p>
-            <a:pPr lvl="0"/>
-            <a:r>
-              <a:t>Define the right problem</a:t>
-            </a:r>
-          </a:p>
-          <a:p>
-            <a:pPr lvl="0"/>
-            <a:r>
-              <a:t>Evaluate AI output quickly and accurately</a:t>
-            </a:r>
-          </a:p>
-          <a:p>
-            <a:pPr lvl="0"/>
-            <a:r>
-              <a:t>Catch architectural flaws before they compound</a:t>
-            </a:r>
-          </a:p>
-          <a:p>
-            <a:pPr lvl="0"/>
-            <a:r>
-              <a:t>Understand systems well enough to know what the AI got wrong</a:t>
-            </a:r>
-          </a:p>
-          <a:p>
-            <a:pPr marL="0" lvl="0" indent="0">
-              <a:buNone/>
-            </a:pPr>
-            <a:r>
-              <a:t>That is senior-level thinking. Teams may get smaller, but they also need to get more experienced.</a:t>
+              <a:t>Vibe coding doesn’t just change how individuals write code. It reshapes teams, roles, hiring, and the structure of how organizations build software.</a:t>
             </a:r>
           </a:p>
         </p:txBody>
@@ -12527,7 +13074,7 @@
               <a:buNone/>
             </a:pPr>
             <a:r>
-              <a:t>The Conductor Skill Set</a:t>
+              <a:t>Fewer Developers, Higher Seniority</a:t>
             </a:r>
           </a:p>
         </p:txBody>
@@ -12544,66 +13091,56 @@
         </p:nvSpPr>
         <p:spPr/>
         <p:txBody>
-          <a:bodyPr/>
+          <a:bodyPr>
+            <a:normAutofit lnSpcReduction="10000"/>
+          </a:bodyPr>
           <a:lstStyle/>
           <a:p>
             <a:pPr marL="0" lvl="0" indent="0">
               <a:buNone/>
             </a:pPr>
             <a:r>
-              <a:t>The most valuable person in a vibe coding organization is not the fastest typist. It is the person who can orchestrate AI effectively.</a:t>
-            </a:r>
-          </a:p>
-          <a:p>
-            <a:pPr marL="0" lvl="0" indent="0">
-              <a:buNone/>
-            </a:pPr>
-            <a:r>
-              <a:t>Important conductor skills include:</a:t>
-            </a:r>
-          </a:p>
-          <a:p>
-            <a:pPr lvl="0"/>
-            <a:r>
-              <a:t>Problem decomposition</a:t>
-            </a:r>
-          </a:p>
-          <a:p>
-            <a:pPr lvl="0"/>
-            <a:r>
-              <a:t>Precise communication</a:t>
-            </a:r>
-          </a:p>
-          <a:p>
-            <a:pPr lvl="0"/>
-            <a:r>
-              <a:t>Domain expertise</a:t>
-            </a:r>
-          </a:p>
-          <a:p>
-            <a:pPr lvl="0"/>
-            <a:r>
-              <a:t>Taste and judgment</a:t>
-            </a:r>
-          </a:p>
-          <a:p>
-            <a:pPr lvl="0"/>
-            <a:r>
-              <a:t>Security awareness</a:t>
-            </a:r>
-          </a:p>
-          <a:p>
-            <a:pPr lvl="0"/>
-            <a:r>
-              <a:t>Systems thinking</a:t>
-            </a:r>
-          </a:p>
-          <a:p>
-            <a:pPr marL="0" lvl="0" indent="0">
-              <a:buNone/>
-            </a:pPr>
-            <a:r>
-              <a:t>Typing speed and memorized API trivia matter less than they used to.</a:t>
+              <a:t>One immediate effect is that small teams can do work that once required much larger ones. This does not mean organizations need less talent — it means they need different talent.</a:t>
+            </a:r>
+          </a:p>
+          <a:p>
+            <a:pPr marL="0" lvl="0" indent="0">
+              <a:buNone/>
+            </a:pPr>
+            <a:r>
+              <a:t>When AI writes the code, the bottleneck shifts from implementation to judgment. Teams need people who can:</a:t>
+            </a:r>
+          </a:p>
+          <a:p>
+            <a:pPr lvl="0"/>
+            <a:r>
+              <a:t>Define the right problem</a:t>
+            </a:r>
+          </a:p>
+          <a:p>
+            <a:pPr lvl="0"/>
+            <a:r>
+              <a:t>Evaluate AI output quickly and accurately</a:t>
+            </a:r>
+          </a:p>
+          <a:p>
+            <a:pPr lvl="0"/>
+            <a:r>
+              <a:t>Catch architectural flaws before they compound</a:t>
+            </a:r>
+          </a:p>
+          <a:p>
+            <a:pPr lvl="0"/>
+            <a:r>
+              <a:t>Understand systems well enough to know what the AI got wrong</a:t>
+            </a:r>
+          </a:p>
+          <a:p>
+            <a:pPr marL="0" lvl="0" indent="0">
+              <a:buNone/>
+            </a:pPr>
+            <a:r>
+              <a:t>That is senior-level thinking. Teams may get smaller, but they also need to get more experienced.</a:t>
             </a:r>
           </a:p>
         </p:txBody>
@@ -12652,7 +13189,7 @@
               <a:buNone/>
             </a:pPr>
             <a:r>
-              <a:t>Code Review Changes Everything</a:t>
+              <a:t>The Conductor Skill Set</a:t>
             </a:r>
           </a:p>
         </p:txBody>
@@ -12676,57 +13213,59 @@
               <a:buNone/>
             </a:pPr>
             <a:r>
-              <a:t>In traditional development, code review often focused on style, clarity, and correctness. In the vibe coding era, it becomes the primary quality gate.</a:t>
-            </a:r>
-          </a:p>
-          <a:p>
-            <a:pPr marL="0" lvl="0" indent="0">
-              <a:buNone/>
-            </a:pPr>
-            <a:r>
-              <a:t>The questions change from:</a:t>
-            </a:r>
-          </a:p>
-          <a:p>
-            <a:pPr marL="1270000" lvl="0" indent="0">
-              <a:buNone/>
-            </a:pPr>
-            <a:r>
-              <a:rPr sz="2000"/>
-              <a:t>“Did you follow the naming conventions?”</a:t>
-            </a:r>
-          </a:p>
-          <a:p>
-            <a:pPr marL="0" lvl="0" indent="0">
-              <a:buNone/>
-            </a:pPr>
-            <a:r>
-              <a:t>to:</a:t>
-            </a:r>
-          </a:p>
-          <a:p>
-            <a:pPr marL="1270000" lvl="0" indent="0">
-              <a:buNone/>
-            </a:pPr>
-            <a:r>
-              <a:rPr sz="2000"/>
-              <a:t>“Did the AI silently remove the authentication check?”</a:t>
-            </a:r>
-          </a:p>
-          <a:p>
-            <a:pPr marL="0" lvl="0" indent="0">
-              <a:buNone/>
-            </a:pPr>
-            <a:r>
-              <a:t>AI-generated code has a specific failure mode: it looks polished while hiding subtle defects. It compiles, the tests pass, and the code reads cleanly, but the hidden logic is wrong, incomplete, or fragile.</a:t>
-            </a:r>
-          </a:p>
-          <a:p>
-            <a:pPr marL="0" lvl="0" indent="0">
-              <a:buNone/>
-            </a:pPr>
-            <a:r>
-              <a:t>Organizations need to invest more in review skills, not less.</a:t>
+              <a:t>The most valuable person in a vibe coding organization is not the fastest typist. It is the person who can orchestrate AI effectively.</a:t>
+            </a:r>
+          </a:p>
+          <a:p>
+            <a:pPr marL="0" lvl="0" indent="0">
+              <a:buNone/>
+            </a:pPr>
+            <a:r>
+              <a:t>Important conductor skills include:</a:t>
+            </a:r>
+          </a:p>
+          <a:p>
+            <a:pPr lvl="0"/>
+            <a:r>
+              <a:t>Problem decomposition</a:t>
+            </a:r>
+          </a:p>
+          <a:p>
+            <a:pPr lvl="0"/>
+            <a:r>
+              <a:t>Precise communication</a:t>
+            </a:r>
+          </a:p>
+          <a:p>
+            <a:pPr lvl="0"/>
+            <a:r>
+              <a:t>Domain expertise</a:t>
+            </a:r>
+          </a:p>
+          <a:p>
+            <a:pPr lvl="0"/>
+            <a:r>
+              <a:t>Taste and judgment</a:t>
+            </a:r>
+          </a:p>
+          <a:p>
+            <a:pPr lvl="0"/>
+            <a:r>
+              <a:t>Security awareness</a:t>
+            </a:r>
+          </a:p>
+          <a:p>
+            <a:pPr lvl="0"/>
+            <a:r>
+              <a:t>Systems thinking</a:t>
+            </a:r>
+          </a:p>
+          <a:p>
+            <a:pPr marL="0" lvl="0" indent="0">
+              <a:buNone/>
+            </a:pPr>
+            <a:r>
+              <a:t>Typing speed and memorized API trivia matter less than they used to.</a:t>
             </a:r>
           </a:p>
         </p:txBody>
@@ -12775,7 +13314,7 @@
               <a:buNone/>
             </a:pPr>
             <a:r>
-              <a:t>The Senior Developer’s New Role</a:t>
+              <a:t>Code Review Changes Everything</a:t>
             </a:r>
           </a:p>
         </p:txBody>
@@ -12792,120 +13331,64 @@
         </p:nvSpPr>
         <p:spPr/>
         <p:txBody>
-          <a:bodyPr>
-            <a:normAutofit fontScale="55000" lnSpcReduction="20000"/>
-          </a:bodyPr>
+          <a:bodyPr/>
           <a:lstStyle/>
           <a:p>
             <a:pPr marL="0" lvl="0" indent="0">
               <a:buNone/>
             </a:pPr>
             <a:r>
-              <a:t>Senior developers are more important than ever, but their job changes.</a:t>
-            </a:r>
-          </a:p>
-          <a:p>
-            <a:pPr marL="0" lvl="0" indent="0">
-              <a:spcBef>
-                <a:spcPts val="3000"/>
-              </a:spcBef>
-              <a:buNone/>
-            </a:pPr>
-            <a:r>
-              <a:rPr b="1"/>
-              <a:t>Before vibe coding</a:t>
-            </a:r>
-          </a:p>
-          <a:p>
-            <a:pPr lvl="0"/>
-            <a:r>
-              <a:t>Write complex code</a:t>
-            </a:r>
-          </a:p>
-          <a:p>
-            <a:pPr lvl="0"/>
-            <a:r>
-              <a:t>Mentor juniors on implementation</a:t>
-            </a:r>
-          </a:p>
-          <a:p>
-            <a:pPr lvl="0"/>
-            <a:r>
-              <a:t>Architect systems</a:t>
-            </a:r>
-          </a:p>
-          <a:p>
-            <a:pPr lvl="0"/>
-            <a:r>
-              <a:t>Review code</a:t>
-            </a:r>
-          </a:p>
-          <a:p>
-            <a:pPr lvl="0"/>
-            <a:r>
-              <a:t>Debug production issues</a:t>
-            </a:r>
-          </a:p>
-          <a:p>
-            <a:pPr marL="0" lvl="0" indent="0">
-              <a:spcBef>
-                <a:spcPts val="3000"/>
-              </a:spcBef>
-              <a:buNone/>
-            </a:pPr>
-            <a:r>
-              <a:rPr b="1"/>
-              <a:t>After vibe coding</a:t>
-            </a:r>
-          </a:p>
-          <a:p>
-            <a:pPr lvl="0"/>
-            <a:r>
-              <a:t>Architect systems</a:t>
-            </a:r>
-          </a:p>
-          <a:p>
-            <a:pPr lvl="0"/>
-            <a:r>
-              <a:t>Review AI-generated code</a:t>
-            </a:r>
-          </a:p>
-          <a:p>
-            <a:pPr lvl="0"/>
-            <a:r>
-              <a:t>Define prompts and specifications</a:t>
-            </a:r>
-          </a:p>
-          <a:p>
-            <a:pPr lvl="0"/>
-            <a:r>
-              <a:t>Evaluate and select AI tools</a:t>
-            </a:r>
-          </a:p>
-          <a:p>
-            <a:pPr lvl="0"/>
-            <a:r>
-              <a:t>Set security and quality guardrails</a:t>
-            </a:r>
-          </a:p>
-          <a:p>
-            <a:pPr lvl="0"/>
-            <a:r>
-              <a:t>Debug production issues</a:t>
-            </a:r>
-          </a:p>
-          <a:p>
-            <a:pPr lvl="0"/>
-            <a:r>
-              <a:t>Mentor teams on when and how to use AI</a:t>
-            </a:r>
-          </a:p>
-          <a:p>
-            <a:pPr marL="0" lvl="0" indent="0">
-              <a:buNone/>
-            </a:pPr>
-            <a:r>
-              <a:t>The shift is from pure implementation toward player-coach behavior.</a:t>
+              <a:t>In traditional development, code review often focused on style, clarity, and correctness. In the vibe coding era, it becomes the primary quality gate.</a:t>
+            </a:r>
+          </a:p>
+          <a:p>
+            <a:pPr marL="0" lvl="0" indent="0">
+              <a:buNone/>
+            </a:pPr>
+            <a:r>
+              <a:t>The questions change from:</a:t>
+            </a:r>
+          </a:p>
+          <a:p>
+            <a:pPr marL="1270000" lvl="0" indent="0">
+              <a:buNone/>
+            </a:pPr>
+            <a:r>
+              <a:rPr sz="2000"/>
+              <a:t>“Did you follow the naming conventions?”</a:t>
+            </a:r>
+          </a:p>
+          <a:p>
+            <a:pPr marL="0" lvl="0" indent="0">
+              <a:buNone/>
+            </a:pPr>
+            <a:r>
+              <a:t>to:</a:t>
+            </a:r>
+          </a:p>
+          <a:p>
+            <a:pPr marL="1270000" lvl="0" indent="0">
+              <a:buNone/>
+            </a:pPr>
+            <a:r>
+              <a:rPr sz="2000"/>
+              <a:t>“Did the AI silently remove the authentication check?”</a:t>
+            </a:r>
+          </a:p>
+          <a:p>
+            <a:pPr marL="0" lvl="0" indent="0">
+              <a:buNone/>
+            </a:pPr>
+            <a:r>
+              <a:t>AI-generated code has a specific failure mode: it looks polished while hiding subtle defects. It compiles, the tests pass, and the code reads cleanly, but the hidden logic is wrong, incomplete, or fragile.</a:t>
+            </a:r>
+          </a:p>
+          <a:p>
+            <a:pPr marL="0" lvl="0" indent="0">
+              <a:buNone/>
+            </a:pPr>
+            <a:r>
+              <a:t>Organizations need to invest more in review skills, not less.</a:t>
             </a:r>
           </a:p>
         </p:txBody>
@@ -12954,7 +13437,7 @@
               <a:buNone/>
             </a:pPr>
             <a:r>
-              <a:t>The Shadow IT Problem</a:t>
+              <a:t>The Senior Developer’s New Role</a:t>
             </a:r>
           </a:p>
         </p:txBody>
@@ -12971,54 +13454,120 @@
         </p:nvSpPr>
         <p:spPr/>
         <p:txBody>
-          <a:bodyPr/>
+          <a:bodyPr>
+            <a:normAutofit fontScale="55000" lnSpcReduction="20000"/>
+          </a:bodyPr>
           <a:lstStyle/>
           <a:p>
             <a:pPr marL="0" lvl="0" indent="0">
               <a:buNone/>
             </a:pPr>
             <a:r>
-              <a:t>Every large organization already has shadow vibe coders: program managers building dashboards, marketing teams creating landing pages, analysts automating reports, all outside formal governance.</a:t>
-            </a:r>
-          </a:p>
-          <a:p>
-            <a:pPr marL="0" lvl="0" indent="0">
-              <a:buNone/>
-            </a:pPr>
-            <a:r>
-              <a:t>Organizations effectively have three options:</a:t>
-            </a:r>
-          </a:p>
-          <a:p>
-            <a:pPr marL="342900" lvl="0" indent="-342900">
-              <a:buAutoNum type="arabicPeriod"/>
-            </a:pPr>
-            <a:r>
-              <a:t>Ignore it</a:t>
-            </a:r>
-          </a:p>
-          <a:p>
-            <a:pPr marL="342900" lvl="0" indent="-342900">
-              <a:buAutoNum type="arabicPeriod"/>
-            </a:pPr>
-            <a:r>
-              <a:t>Ban it</a:t>
-            </a:r>
-          </a:p>
-          <a:p>
-            <a:pPr marL="342900" lvl="0" indent="-342900">
-              <a:buAutoNum type="arabicPeriod"/>
-            </a:pPr>
-            <a:r>
-              <a:t>Govern it</a:t>
-            </a:r>
-          </a:p>
-          <a:p>
-            <a:pPr marL="0" lvl="0" indent="0">
-              <a:buNone/>
-            </a:pPr>
-            <a:r>
-              <a:t>Only the third option scales. Provide approved tools, training, guardrails, and a sane review path. Make it easier to do the right thing than the wrong thing.</a:t>
+              <a:t>Senior developers are more important than ever, but their job changes.</a:t>
+            </a:r>
+          </a:p>
+          <a:p>
+            <a:pPr marL="0" lvl="0" indent="0">
+              <a:spcBef>
+                <a:spcPts val="3000"/>
+              </a:spcBef>
+              <a:buNone/>
+            </a:pPr>
+            <a:r>
+              <a:rPr b="1"/>
+              <a:t>Before vibe coding</a:t>
+            </a:r>
+          </a:p>
+          <a:p>
+            <a:pPr lvl="0"/>
+            <a:r>
+              <a:t>Write complex code</a:t>
+            </a:r>
+          </a:p>
+          <a:p>
+            <a:pPr lvl="0"/>
+            <a:r>
+              <a:t>Mentor juniors on implementation</a:t>
+            </a:r>
+          </a:p>
+          <a:p>
+            <a:pPr lvl="0"/>
+            <a:r>
+              <a:t>Architect systems</a:t>
+            </a:r>
+          </a:p>
+          <a:p>
+            <a:pPr lvl="0"/>
+            <a:r>
+              <a:t>Review code</a:t>
+            </a:r>
+          </a:p>
+          <a:p>
+            <a:pPr lvl="0"/>
+            <a:r>
+              <a:t>Debug production issues</a:t>
+            </a:r>
+          </a:p>
+          <a:p>
+            <a:pPr marL="0" lvl="0" indent="0">
+              <a:spcBef>
+                <a:spcPts val="3000"/>
+              </a:spcBef>
+              <a:buNone/>
+            </a:pPr>
+            <a:r>
+              <a:rPr b="1"/>
+              <a:t>After vibe coding</a:t>
+            </a:r>
+          </a:p>
+          <a:p>
+            <a:pPr lvl="0"/>
+            <a:r>
+              <a:t>Architect systems</a:t>
+            </a:r>
+          </a:p>
+          <a:p>
+            <a:pPr lvl="0"/>
+            <a:r>
+              <a:t>Review AI-generated code</a:t>
+            </a:r>
+          </a:p>
+          <a:p>
+            <a:pPr lvl="0"/>
+            <a:r>
+              <a:t>Define prompts and specifications</a:t>
+            </a:r>
+          </a:p>
+          <a:p>
+            <a:pPr lvl="0"/>
+            <a:r>
+              <a:t>Evaluate and select AI tools</a:t>
+            </a:r>
+          </a:p>
+          <a:p>
+            <a:pPr lvl="0"/>
+            <a:r>
+              <a:t>Set security and quality guardrails</a:t>
+            </a:r>
+          </a:p>
+          <a:p>
+            <a:pPr lvl="0"/>
+            <a:r>
+              <a:t>Debug production issues</a:t>
+            </a:r>
+          </a:p>
+          <a:p>
+            <a:pPr lvl="0"/>
+            <a:r>
+              <a:t>Mentor teams on when and how to use AI</a:t>
+            </a:r>
+          </a:p>
+          <a:p>
+            <a:pPr marL="0" lvl="0" indent="0">
+              <a:buNone/>
+            </a:pPr>
+            <a:r>
+              <a:t>The shift is from pure implementation toward player-coach behavior.</a:t>
             </a:r>
           </a:p>
         </p:txBody>
@@ -13104,7 +13653,7 @@
         </p:nvGraphicFramePr>
         <p:xfrm>
           <a:off x="3568700" y="203200"/>
-          <a:ext cx="5105400" cy="4381500"/>
+          <a:ext cx="5105400" cy="1188720"/>
         </p:xfrm>
         <a:graphic>
           <a:graphicData uri="http://schemas.openxmlformats.org/drawingml/2006/table">
@@ -13324,7 +13873,7 @@
               <a:buNone/>
             </a:pPr>
             <a:r>
-              <a:t>The Productivity Paradox at Scale</a:t>
+              <a:t>The Shadow IT Problem</a:t>
             </a:r>
           </a:p>
         </p:txBody>
@@ -13348,47 +13897,47 @@
               <a:buNone/>
             </a:pPr>
             <a:r>
-              <a:t>Individual vibe coders often report dramatic speedups, but organizations do not always see equivalent gains.</a:t>
-            </a:r>
-          </a:p>
-          <a:p>
-            <a:pPr marL="0" lvl="0" indent="0">
-              <a:buNone/>
-            </a:pPr>
-            <a:r>
-              <a:t>Why not?</a:t>
-            </a:r>
-          </a:p>
-          <a:p>
-            <a:pPr lvl="0"/>
-            <a:r>
-              <a:t>The bottleneck shifts to requirements, review, testing, deployment, and maintenance</a:t>
-            </a:r>
-          </a:p>
-          <a:p>
-            <a:pPr lvl="0"/>
-            <a:r>
-              <a:t>Review overhead increases</a:t>
-            </a:r>
-          </a:p>
-          <a:p>
-            <a:pPr lvl="0"/>
-            <a:r>
-              <a:t>Technical debt can accumulate faster</a:t>
-            </a:r>
-          </a:p>
-          <a:p>
-            <a:pPr lvl="0"/>
-            <a:r>
-              <a:t>Coordination costs between people still remain</a:t>
-            </a:r>
-          </a:p>
-          <a:p>
-            <a:pPr marL="0" lvl="0" indent="0">
-              <a:buNone/>
-            </a:pPr>
-            <a:r>
-              <a:t>The short-term organizational gain is usually meaningful but not magical.</a:t>
+              <a:t>Every large organization already has shadow vibe coders: program managers building dashboards, marketing teams creating landing pages, analysts automating reports, all outside formal governance.</a:t>
+            </a:r>
+          </a:p>
+          <a:p>
+            <a:pPr marL="0" lvl="0" indent="0">
+              <a:buNone/>
+            </a:pPr>
+            <a:r>
+              <a:t>Organizations effectively have three options:</a:t>
+            </a:r>
+          </a:p>
+          <a:p>
+            <a:pPr marL="342900" lvl="0" indent="-342900">
+              <a:buAutoNum type="arabicPeriod"/>
+            </a:pPr>
+            <a:r>
+              <a:t>Ignore it</a:t>
+            </a:r>
+          </a:p>
+          <a:p>
+            <a:pPr marL="342900" lvl="0" indent="-342900">
+              <a:buAutoNum type="arabicPeriod"/>
+            </a:pPr>
+            <a:r>
+              <a:t>Ban it</a:t>
+            </a:r>
+          </a:p>
+          <a:p>
+            <a:pPr marL="342900" lvl="0" indent="-342900">
+              <a:buAutoNum type="arabicPeriod"/>
+            </a:pPr>
+            <a:r>
+              <a:t>Govern it</a:t>
+            </a:r>
+          </a:p>
+          <a:p>
+            <a:pPr marL="0" lvl="0" indent="0">
+              <a:buNone/>
+            </a:pPr>
+            <a:r>
+              <a:t>Only the third option scales. Provide approved tools, training, guardrails, and a sane review path. Make it easier to do the right thing than the wrong thing.</a:t>
             </a:r>
           </a:p>
         </p:txBody>
@@ -13437,7 +13986,7 @@
               <a:buNone/>
             </a:pPr>
             <a:r>
-              <a:t>Build vs. Buy vs. Vibe</a:t>
+              <a:t>The Productivity Paradox at Scale</a:t>
             </a:r>
           </a:p>
         </p:txBody>
@@ -13454,118 +14003,54 @@
         </p:nvSpPr>
         <p:spPr/>
         <p:txBody>
-          <a:bodyPr>
-            <a:normAutofit fontScale="47500" lnSpcReduction="20000"/>
-          </a:bodyPr>
+          <a:bodyPr/>
           <a:lstStyle/>
           <a:p>
             <a:pPr marL="0" lvl="0" indent="0">
               <a:buNone/>
             </a:pPr>
             <a:r>
-              <a:t>Not everything should be vibe coded.</a:t>
-            </a:r>
-          </a:p>
-          <a:p>
-            <a:pPr marL="0" lvl="0" indent="0">
-              <a:spcBef>
-                <a:spcPts val="3000"/>
-              </a:spcBef>
-              <a:buNone/>
-            </a:pPr>
-            <a:r>
-              <a:rPr b="1"/>
-              <a:t>Vibe code it when:</a:t>
-            </a:r>
-          </a:p>
-          <a:p>
-            <a:pPr lvl="0"/>
-            <a:r>
-              <a:t>It is an internal tool</a:t>
-            </a:r>
-          </a:p>
-          <a:p>
-            <a:pPr lvl="0"/>
-            <a:r>
-              <a:t>The data is not highly sensitive</a:t>
-            </a:r>
-          </a:p>
-          <a:p>
-            <a:pPr lvl="0"/>
-            <a:r>
-              <a:t>The scope is bounded</a:t>
-            </a:r>
-          </a:p>
-          <a:p>
-            <a:pPr lvl="0"/>
-            <a:r>
-              <a:t>Someone can competently review the output</a:t>
-            </a:r>
-          </a:p>
-          <a:p>
-            <a:pPr marL="0" lvl="0" indent="0">
-              <a:spcBef>
-                <a:spcPts val="3000"/>
-              </a:spcBef>
-              <a:buNone/>
-            </a:pPr>
-            <a:r>
-              <a:rPr b="1"/>
-              <a:t>Buy SaaS when:</a:t>
-            </a:r>
-          </a:p>
-          <a:p>
-            <a:pPr lvl="0"/>
-            <a:r>
-              <a:t>The problem is already well solved</a:t>
-            </a:r>
-          </a:p>
-          <a:p>
-            <a:pPr lvl="0"/>
-            <a:r>
-              <a:t>Compliance matters more than customization</a:t>
-            </a:r>
-          </a:p>
-          <a:p>
-            <a:pPr lvl="0"/>
-            <a:r>
-              <a:t>Long-term maintenance is more important than speed</a:t>
-            </a:r>
-          </a:p>
-          <a:p>
-            <a:pPr marL="0" lvl="0" indent="0">
-              <a:spcBef>
-                <a:spcPts val="3000"/>
-              </a:spcBef>
-              <a:buNone/>
-            </a:pPr>
-            <a:r>
-              <a:rPr b="1"/>
-              <a:t>Use traditional engineering when:</a:t>
-            </a:r>
-          </a:p>
-          <a:p>
-            <a:pPr lvl="0"/>
-            <a:r>
-              <a:t>The system is mission critical</a:t>
-            </a:r>
-          </a:p>
-          <a:p>
-            <a:pPr lvl="0"/>
-            <a:r>
-              <a:t>It handles financial, medical, or legal data</a:t>
-            </a:r>
-          </a:p>
-          <a:p>
-            <a:pPr lvl="0"/>
-            <a:r>
-              <a:t>It requires regulatory compliance</a:t>
-            </a:r>
-          </a:p>
-          <a:p>
-            <a:pPr lvl="0"/>
-            <a:r>
-              <a:t>It needs to scale hard</a:t>
+              <a:t>Individual vibe coders often report dramatic speedups, but organizations do not always see equivalent gains.</a:t>
+            </a:r>
+          </a:p>
+          <a:p>
+            <a:pPr marL="0" lvl="0" indent="0">
+              <a:buNone/>
+            </a:pPr>
+            <a:r>
+              <a:t>Why not?</a:t>
+            </a:r>
+          </a:p>
+          <a:p>
+            <a:pPr lvl="0"/>
+            <a:r>
+              <a:t>The bottleneck shifts to requirements, review, testing, deployment, and maintenance</a:t>
+            </a:r>
+          </a:p>
+          <a:p>
+            <a:pPr lvl="0"/>
+            <a:r>
+              <a:t>Review overhead increases</a:t>
+            </a:r>
+          </a:p>
+          <a:p>
+            <a:pPr lvl="0"/>
+            <a:r>
+              <a:t>Technical debt can accumulate faster</a:t>
+            </a:r>
+          </a:p>
+          <a:p>
+            <a:pPr lvl="0"/>
+            <a:r>
+              <a:t>Coordination costs between people still remain</a:t>
+            </a:r>
+          </a:p>
+          <a:p>
+            <a:pPr marL="0" lvl="0" indent="0">
+              <a:buNone/>
+            </a:pPr>
+            <a:r>
+              <a:t>The short-term organizational gain is usually meaningful but not magical.</a:t>
             </a:r>
           </a:p>
         </p:txBody>
@@ -13614,7 +14099,7 @@
               <a:buNone/>
             </a:pPr>
             <a:r>
-              <a:t>Broken Metrics</a:t>
+              <a:t>Build vs. Buy vs. Vibe</a:t>
             </a:r>
           </a:p>
         </p:txBody>
@@ -13631,60 +14116,118 @@
         </p:nvSpPr>
         <p:spPr/>
         <p:txBody>
-          <a:bodyPr/>
+          <a:bodyPr>
+            <a:normAutofit fontScale="47500" lnSpcReduction="20000"/>
+          </a:bodyPr>
           <a:lstStyle/>
           <a:p>
             <a:pPr marL="0" lvl="0" indent="0">
               <a:buNone/>
             </a:pPr>
             <a:r>
-              <a:t>Traditional productivity metrics are poor fits for vibe coding.</a:t>
-            </a:r>
-          </a:p>
-          <a:p>
-            <a:pPr marL="0" lvl="0" indent="0">
-              <a:buNone/>
-            </a:pPr>
-            <a:r>
-              <a:t>Metrics that matter more include:</a:t>
-            </a:r>
-          </a:p>
-          <a:p>
-            <a:pPr lvl="0"/>
-            <a:r>
-              <a:t>Prompt-to-Ship Time</a:t>
-            </a:r>
-          </a:p>
-          <a:p>
-            <a:pPr lvl="0"/>
-            <a:r>
-              <a:t>AI Code Review Pass Rate</a:t>
-            </a:r>
-          </a:p>
-          <a:p>
-            <a:pPr lvl="0"/>
-            <a:r>
-              <a:t>Rework Rate</a:t>
-            </a:r>
-          </a:p>
-          <a:p>
-            <a:pPr lvl="0"/>
-            <a:r>
-              <a:t>Incident Rate</a:t>
-            </a:r>
-          </a:p>
-          <a:p>
-            <a:pPr lvl="0"/>
-            <a:r>
-              <a:t>System Complexity Capability</a:t>
-            </a:r>
-          </a:p>
-          <a:p>
-            <a:pPr marL="0" lvl="0" indent="0">
-              <a:buNone/>
-            </a:pPr>
-            <a:r>
-              <a:t>Measure outcomes, not line counts.</a:t>
+              <a:t>Not everything should be vibe coded.</a:t>
+            </a:r>
+          </a:p>
+          <a:p>
+            <a:pPr marL="0" lvl="0" indent="0">
+              <a:spcBef>
+                <a:spcPts val="3000"/>
+              </a:spcBef>
+              <a:buNone/>
+            </a:pPr>
+            <a:r>
+              <a:rPr b="1"/>
+              <a:t>Vibe code it when:</a:t>
+            </a:r>
+          </a:p>
+          <a:p>
+            <a:pPr lvl="0"/>
+            <a:r>
+              <a:t>It is an internal tool</a:t>
+            </a:r>
+          </a:p>
+          <a:p>
+            <a:pPr lvl="0"/>
+            <a:r>
+              <a:t>The data is not highly sensitive</a:t>
+            </a:r>
+          </a:p>
+          <a:p>
+            <a:pPr lvl="0"/>
+            <a:r>
+              <a:t>The scope is bounded</a:t>
+            </a:r>
+          </a:p>
+          <a:p>
+            <a:pPr lvl="0"/>
+            <a:r>
+              <a:t>Someone can competently review the output</a:t>
+            </a:r>
+          </a:p>
+          <a:p>
+            <a:pPr marL="0" lvl="0" indent="0">
+              <a:spcBef>
+                <a:spcPts val="3000"/>
+              </a:spcBef>
+              <a:buNone/>
+            </a:pPr>
+            <a:r>
+              <a:rPr b="1"/>
+              <a:t>Buy SaaS when:</a:t>
+            </a:r>
+          </a:p>
+          <a:p>
+            <a:pPr lvl="0"/>
+            <a:r>
+              <a:t>The problem is already well solved</a:t>
+            </a:r>
+          </a:p>
+          <a:p>
+            <a:pPr lvl="0"/>
+            <a:r>
+              <a:t>Compliance matters more than customization</a:t>
+            </a:r>
+          </a:p>
+          <a:p>
+            <a:pPr lvl="0"/>
+            <a:r>
+              <a:t>Long-term maintenance is more important than speed</a:t>
+            </a:r>
+          </a:p>
+          <a:p>
+            <a:pPr marL="0" lvl="0" indent="0">
+              <a:spcBef>
+                <a:spcPts val="3000"/>
+              </a:spcBef>
+              <a:buNone/>
+            </a:pPr>
+            <a:r>
+              <a:rPr b="1"/>
+              <a:t>Use traditional engineering when:</a:t>
+            </a:r>
+          </a:p>
+          <a:p>
+            <a:pPr lvl="0"/>
+            <a:r>
+              <a:t>The system is mission critical</a:t>
+            </a:r>
+          </a:p>
+          <a:p>
+            <a:pPr lvl="0"/>
+            <a:r>
+              <a:t>It handles financial, medical, or legal data</a:t>
+            </a:r>
+          </a:p>
+          <a:p>
+            <a:pPr lvl="0"/>
+            <a:r>
+              <a:t>It requires regulatory compliance</a:t>
+            </a:r>
+          </a:p>
+          <a:p>
+            <a:pPr lvl="0"/>
+            <a:r>
+              <a:t>It needs to scale hard</a:t>
             </a:r>
           </a:p>
         </p:txBody>
@@ -13733,7 +14276,7 @@
               <a:buNone/>
             </a:pPr>
             <a:r>
-              <a:t>Cultural Resistance</a:t>
+              <a:t>Broken Metrics</a:t>
             </a:r>
           </a:p>
         </p:txBody>
@@ -13757,39 +14300,53 @@
               <a:buNone/>
             </a:pPr>
             <a:r>
-              <a:t>Expect friction from several directions:</a:t>
-            </a:r>
-          </a:p>
-          <a:p>
-            <a:pPr lvl="0"/>
-            <a:r>
-              <a:t>Not Invented Here reactions</a:t>
-            </a:r>
-          </a:p>
-          <a:p>
-            <a:pPr lvl="0"/>
-            <a:r>
-              <a:t>Fear of obsolescence</a:t>
-            </a:r>
-          </a:p>
-          <a:p>
-            <a:pPr lvl="0"/>
-            <a:r>
-              <a:t>Generational disagreements</a:t>
-            </a:r>
-          </a:p>
-          <a:p>
-            <a:pPr lvl="0"/>
-            <a:r>
-              <a:t>Over-trust in AI output</a:t>
-            </a:r>
-          </a:p>
-          <a:p>
-            <a:pPr marL="0" lvl="0" indent="0">
-              <a:buNone/>
-            </a:pPr>
-            <a:r>
-              <a:t>The most dangerous cultural problem is not skepticism. It is uncritical acceptance.</a:t>
+              <a:t>Traditional productivity metrics are poor fits for vibe coding.</a:t>
+            </a:r>
+          </a:p>
+          <a:p>
+            <a:pPr marL="0" lvl="0" indent="0">
+              <a:buNone/>
+            </a:pPr>
+            <a:r>
+              <a:t>Metrics that matter more include:</a:t>
+            </a:r>
+          </a:p>
+          <a:p>
+            <a:pPr lvl="0"/>
+            <a:r>
+              <a:t>Prompt-to-Ship Time</a:t>
+            </a:r>
+          </a:p>
+          <a:p>
+            <a:pPr lvl="0"/>
+            <a:r>
+              <a:t>AI Code Review Pass Rate</a:t>
+            </a:r>
+          </a:p>
+          <a:p>
+            <a:pPr lvl="0"/>
+            <a:r>
+              <a:t>Rework Rate</a:t>
+            </a:r>
+          </a:p>
+          <a:p>
+            <a:pPr lvl="0"/>
+            <a:r>
+              <a:t>Incident Rate</a:t>
+            </a:r>
+          </a:p>
+          <a:p>
+            <a:pPr lvl="0"/>
+            <a:r>
+              <a:t>System Complexity Capability</a:t>
+            </a:r>
+          </a:p>
+          <a:p>
+            <a:pPr marL="0" lvl="0" indent="0">
+              <a:buNone/>
+            </a:pPr>
+            <a:r>
+              <a:t>Measure outcomes, not line counts.</a:t>
             </a:r>
           </a:p>
         </p:txBody>
@@ -13838,7 +14395,7 @@
               <a:buNone/>
             </a:pPr>
             <a:r>
-              <a:t>Where Vibe Coding Hits a Wall</a:t>
+              <a:t>Cultural Resistance</a:t>
             </a:r>
           </a:p>
         </p:txBody>
@@ -13862,33 +14419,39 @@
               <a:buNone/>
             </a:pPr>
             <a:r>
-              <a:t>Some domains still resist this workflow:</a:t>
-            </a:r>
-          </a:p>
-          <a:p>
-            <a:pPr lvl="0"/>
-            <a:r>
-              <a:t>Regulated industries</a:t>
-            </a:r>
-          </a:p>
-          <a:p>
-            <a:pPr lvl="0"/>
-            <a:r>
-              <a:t>Real-time and embedded systems</a:t>
-            </a:r>
-          </a:p>
-          <a:p>
-            <a:pPr lvl="0"/>
-            <a:r>
-              <a:t>Large legacy codebases</a:t>
-            </a:r>
-          </a:p>
-          <a:p>
-            <a:pPr marL="0" lvl="0" indent="0">
-              <a:buNone/>
-            </a:pPr>
-            <a:r>
-              <a:t>Knowing when not to use AI may be one of the highest-value skills in the entire stack.</a:t>
+              <a:t>Expect friction from several directions:</a:t>
+            </a:r>
+          </a:p>
+          <a:p>
+            <a:pPr lvl="0"/>
+            <a:r>
+              <a:t>Not Invented Here reactions</a:t>
+            </a:r>
+          </a:p>
+          <a:p>
+            <a:pPr lvl="0"/>
+            <a:r>
+              <a:t>Fear of obsolescence</a:t>
+            </a:r>
+          </a:p>
+          <a:p>
+            <a:pPr lvl="0"/>
+            <a:r>
+              <a:t>Generational disagreements</a:t>
+            </a:r>
+          </a:p>
+          <a:p>
+            <a:pPr lvl="0"/>
+            <a:r>
+              <a:t>Over-trust in AI output</a:t>
+            </a:r>
+          </a:p>
+          <a:p>
+            <a:pPr marL="0" lvl="0" indent="0">
+              <a:buNone/>
+            </a:pPr>
+            <a:r>
+              <a:t>The most dangerous cultural problem is not skepticism. It is uncritical acceptance.</a:t>
             </a:r>
           </a:p>
         </p:txBody>
@@ -13937,7 +14500,7 @@
               <a:buNone/>
             </a:pPr>
             <a:r>
-              <a:t>What to Teach Your Teams</a:t>
+              <a:t>Where Vibe Coding Hits a Wall</a:t>
             </a:r>
           </a:p>
         </p:txBody>
@@ -13961,55 +14524,33 @@
               <a:buNone/>
             </a:pPr>
             <a:r>
-              <a:t>If you’re training an existing team, focus on:</a:t>
-            </a:r>
-          </a:p>
-          <a:p>
-            <a:pPr marL="342900" lvl="0" indent="-342900">
-              <a:buAutoNum type="arabicPeriod"/>
-            </a:pPr>
-            <a:r>
-              <a:t>Prompt engineering basics</a:t>
-            </a:r>
-          </a:p>
-          <a:p>
-            <a:pPr marL="342900" lvl="0" indent="-342900">
-              <a:buAutoNum type="arabicPeriod"/>
-            </a:pPr>
-            <a:r>
-              <a:t>Security awareness</a:t>
-            </a:r>
-          </a:p>
-          <a:p>
-            <a:pPr marL="342900" lvl="0" indent="-342900">
-              <a:buAutoNum type="arabicPeriod"/>
-            </a:pPr>
-            <a:r>
-              <a:t>AI-assisted code review</a:t>
-            </a:r>
-          </a:p>
-          <a:p>
-            <a:pPr marL="342900" lvl="0" indent="-342900">
-              <a:buAutoNum type="arabicPeriod"/>
-            </a:pPr>
-            <a:r>
-              <a:t>Tool literacy</a:t>
-            </a:r>
-          </a:p>
-          <a:p>
-            <a:pPr marL="342900" lvl="0" indent="-342900">
-              <a:buAutoNum type="arabicPeriod"/>
-            </a:pPr>
-            <a:r>
-              <a:t>Knowing when not to use AI</a:t>
-            </a:r>
-          </a:p>
-          <a:p>
-            <a:pPr marL="0" lvl="0" indent="0">
-              <a:buNone/>
-            </a:pPr>
-            <a:r>
-              <a:t>The key lesson is not technical. It is judgment.</a:t>
+              <a:t>Some domains still resist this workflow:</a:t>
+            </a:r>
+          </a:p>
+          <a:p>
+            <a:pPr lvl="0"/>
+            <a:r>
+              <a:t>Regulated industries</a:t>
+            </a:r>
+          </a:p>
+          <a:p>
+            <a:pPr lvl="0"/>
+            <a:r>
+              <a:t>Real-time and embedded systems</a:t>
+            </a:r>
+          </a:p>
+          <a:p>
+            <a:pPr lvl="0"/>
+            <a:r>
+              <a:t>Large legacy codebases</a:t>
+            </a:r>
+          </a:p>
+          <a:p>
+            <a:pPr marL="0" lvl="0" indent="0">
+              <a:buNone/>
+            </a:pPr>
+            <a:r>
+              <a:t>Knowing when not to use AI may be one of the highest-value skills in the entire stack.</a:t>
             </a:r>
           </a:p>
         </p:txBody>
@@ -14049,12 +14590,7 @@
             <p:ph type="title"/>
           </p:nvPr>
         </p:nvSpPr>
-        <p:spPr>
-          <a:xfrm>
-            <a:off x="722313" y="3305176"/>
-            <a:ext cx="7772400" cy="1021556"/>
-          </a:xfrm>
-        </p:spPr>
+        <p:spPr/>
         <p:txBody>
           <a:bodyPr/>
           <a:lstStyle/>
@@ -14063,7 +14599,79 @@
               <a:buNone/>
             </a:pPr>
             <a:r>
-              <a:t>Chapter 8: Future Outlook</a:t>
+              <a:t>What to Teach Your Teams</a:t>
+            </a:r>
+          </a:p>
+        </p:txBody>
+      </p:sp>
+      <p:sp>
+        <p:nvSpPr>
+          <p:cNvPr id="3" name="Content Placeholder 2"/>
+          <p:cNvSpPr>
+            <a:spLocks noGrp="1"/>
+          </p:cNvSpPr>
+          <p:nvPr>
+            <p:ph idx="1"/>
+          </p:nvPr>
+        </p:nvSpPr>
+        <p:spPr/>
+        <p:txBody>
+          <a:bodyPr/>
+          <a:lstStyle/>
+          <a:p>
+            <a:pPr marL="0" lvl="0" indent="0">
+              <a:buNone/>
+            </a:pPr>
+            <a:r>
+              <a:t>If you’re training an existing team, focus on:</a:t>
+            </a:r>
+          </a:p>
+          <a:p>
+            <a:pPr marL="342900" lvl="0" indent="-342900">
+              <a:buAutoNum type="arabicPeriod"/>
+            </a:pPr>
+            <a:r>
+              <a:t>Prompt engineering basics</a:t>
+            </a:r>
+          </a:p>
+          <a:p>
+            <a:pPr marL="342900" lvl="0" indent="-342900">
+              <a:buAutoNum type="arabicPeriod"/>
+            </a:pPr>
+            <a:r>
+              <a:t>Security awareness</a:t>
+            </a:r>
+          </a:p>
+          <a:p>
+            <a:pPr marL="342900" lvl="0" indent="-342900">
+              <a:buAutoNum type="arabicPeriod"/>
+            </a:pPr>
+            <a:r>
+              <a:t>AI-assisted code review</a:t>
+            </a:r>
+          </a:p>
+          <a:p>
+            <a:pPr marL="342900" lvl="0" indent="-342900">
+              <a:buAutoNum type="arabicPeriod"/>
+            </a:pPr>
+            <a:r>
+              <a:t>Tool literacy</a:t>
+            </a:r>
+          </a:p>
+          <a:p>
+            <a:pPr marL="342900" lvl="0" indent="-342900">
+              <a:buAutoNum type="arabicPeriod"/>
+            </a:pPr>
+            <a:r>
+              <a:t>Knowing when not to use AI</a:t>
+            </a:r>
+          </a:p>
+          <a:p>
+            <a:pPr marL="0" lvl="0" indent="0">
+              <a:buNone/>
+            </a:pPr>
+            <a:r>
+              <a:t>The key lesson is not technical. It is judgment.</a:t>
             </a:r>
           </a:p>
         </p:txBody>
@@ -14095,15 +14703,20 @@
       </p:grpSpPr>
       <p:sp>
         <p:nvSpPr>
-          <p:cNvPr id="3" name="Content Placeholder 2"/>
-          <p:cNvSpPr>
-            <a:spLocks noGrp="1"/>
-          </p:cNvSpPr>
-          <p:nvPr>
-            <p:ph idx="1"/>
-          </p:nvPr>
-        </p:nvSpPr>
-        <p:spPr/>
+          <p:cNvPr id="2" name="Title 1"/>
+          <p:cNvSpPr>
+            <a:spLocks noGrp="1"/>
+          </p:cNvSpPr>
+          <p:nvPr>
+            <p:ph type="title"/>
+          </p:nvPr>
+        </p:nvSpPr>
+        <p:spPr>
+          <a:xfrm>
+            <a:off x="722313" y="3305176"/>
+            <a:ext cx="7772400" cy="1021556"/>
+          </a:xfrm>
+        </p:spPr>
         <p:txBody>
           <a:bodyPr/>
           <a:lstStyle/>
@@ -14112,7 +14725,7 @@
               <a:buNone/>
             </a:pPr>
             <a:r>
-              <a:t>Predicting the future of technology is a fool’s errand, but some trajectories are clear enough to be useful.</a:t>
+              <a:t>Chapter 8: Future Outlook</a:t>
             </a:r>
           </a:p>
         </p:txBody>
@@ -14144,12 +14757,12 @@
       </p:grpSpPr>
       <p:sp>
         <p:nvSpPr>
-          <p:cNvPr id="2" name="Title 1"/>
-          <p:cNvSpPr>
-            <a:spLocks noGrp="1"/>
-          </p:cNvSpPr>
-          <p:nvPr>
-            <p:ph type="title"/>
+          <p:cNvPr id="3" name="Content Placeholder 2"/>
+          <p:cNvSpPr>
+            <a:spLocks noGrp="1"/>
+          </p:cNvSpPr>
+          <p:nvPr>
+            <p:ph idx="1"/>
           </p:nvPr>
         </p:nvSpPr>
         <p:spPr/>
@@ -14161,39 +14774,7 @@
               <a:buNone/>
             </a:pPr>
             <a:r>
-              <a:t>Where We Are on the Curve</a:t>
-            </a:r>
-          </a:p>
-        </p:txBody>
-      </p:sp>
-      <p:sp>
-        <p:nvSpPr>
-          <p:cNvPr id="3" name="Content Placeholder 2"/>
-          <p:cNvSpPr>
-            <a:spLocks noGrp="1"/>
-          </p:cNvSpPr>
-          <p:nvPr>
-            <p:ph idx="1"/>
-          </p:nvPr>
-        </p:nvSpPr>
-        <p:spPr/>
-        <p:txBody>
-          <a:bodyPr/>
-          <a:lstStyle/>
-          <a:p>
-            <a:pPr marL="0" lvl="0" indent="0">
-              <a:buNone/>
-            </a:pPr>
-            <a:r>
-              <a:t>Vibe coding in mid-2026 is roughly where smartphones were in 2010. Early adopters have been using it for years. The mainstream is catching up. The tooling works, but it is far from polished.</a:t>
-            </a:r>
-          </a:p>
-          <a:p>
-            <a:pPr marL="0" lvl="0" indent="0">
-              <a:buNone/>
-            </a:pPr>
-            <a:r>
-              <a:t>The industry has already moved past “should we use this?” and into “how do we use this well?”</a:t>
+              <a:t>Predicting the future of technology is a fool’s errand, but some trajectories are clear enough to be useful.</a:t>
             </a:r>
           </a:p>
         </p:txBody>
@@ -14242,7 +14823,7 @@
               <a:buNone/>
             </a:pPr>
             <a:r>
-              <a:t>The Agent Era</a:t>
+              <a:t>Where We Are on the Curve</a:t>
             </a:r>
           </a:p>
         </p:txBody>
@@ -14266,55 +14847,15 @@
               <a:buNone/>
             </a:pPr>
             <a:r>
-              <a:t>The biggest shift underway is not better autocomplete. It is autonomous agents: AI systems that can plan, execute, and iterate with relatively little human intervention.</a:t>
-            </a:r>
-          </a:p>
-          <a:p>
-            <a:pPr marL="0" lvl="0" indent="0">
-              <a:buNone/>
-            </a:pPr>
-            <a:r>
-              <a:t>Examples already in the market include:</a:t>
-            </a:r>
-          </a:p>
-          <a:p>
-            <a:pPr lvl="0"/>
-            <a:r>
-              <a:t>Claude Code reading a codebase, planning multi-step work, writing code, running tests, and fixing failures</a:t>
-            </a:r>
-          </a:p>
-          <a:p>
-            <a:pPr lvl="0"/>
-            <a:r>
-              <a:t>GitHub Copilot launching parallel subagents through </a:t>
-            </a:r>
-            <a:r>
-              <a:rPr>
-                <a:latin typeface="Courier"/>
-              </a:rPr>
-              <a:t>/fleet</a:t>
-            </a:r>
-          </a:p>
-          <a:p>
-            <a:pPr lvl="0"/>
-            <a:r>
-              <a:t>Replit Agent building, testing, and deploying full applications</a:t>
-            </a:r>
-          </a:p>
-          <a:p>
-            <a:pPr marL="0" lvl="0" indent="0">
-              <a:buNone/>
-            </a:pPr>
-            <a:r>
-              <a:t>This is fundamentally different from autocomplete. Autocomplete helps you type faster. Agents do the work.</a:t>
-            </a:r>
-          </a:p>
-          <a:p>
-            <a:pPr marL="0" lvl="0" indent="0">
-              <a:buNone/>
-            </a:pPr>
-            <a:r>
-              <a:t>The human role shifts toward defining goals, reviewing results, and course-correcting.</a:t>
+              <a:t>Vibe coding in mid-2026 is roughly where smartphones were in 2010. Early adopters have been using it for years. The mainstream is catching up. The tooling works, but it is far from polished.</a:t>
+            </a:r>
+          </a:p>
+          <a:p>
+            <a:pPr marL="0" lvl="0" indent="0">
+              <a:buNone/>
+            </a:pPr>
+            <a:r>
+              <a:t>The industry has already moved past “should we use this?” and into “how do we use this well?”</a:t>
             </a:r>
           </a:p>
         </p:txBody>
@@ -14446,7 +14987,7 @@
               <a:buNone/>
             </a:pPr>
             <a:r>
-              <a:t>What Skills Will Matter</a:t>
+              <a:t>The Agent Era</a:t>
             </a:r>
           </a:p>
         </p:txBody>
@@ -14463,154 +15004,62 @@
         </p:nvSpPr>
         <p:spPr/>
         <p:txBody>
-          <a:bodyPr>
-            <a:normAutofit fontScale="40000" lnSpcReduction="20000"/>
-          </a:bodyPr>
+          <a:bodyPr/>
           <a:lstStyle/>
           <a:p>
             <a:pPr marL="0" lvl="0" indent="0">
-              <a:spcBef>
-                <a:spcPts val="3000"/>
-              </a:spcBef>
-              <a:buNone/>
-            </a:pPr>
-            <a:r>
-              <a:rPr b="1"/>
-              <a:t>Increasing in value</a:t>
-            </a:r>
-          </a:p>
-          <a:p>
-            <a:pPr lvl="0"/>
-            <a:r>
-              <a:t>Systems thinking and architecture</a:t>
-            </a:r>
-          </a:p>
-          <a:p>
-            <a:pPr lvl="0"/>
-            <a:r>
-              <a:t>Problem decomposition</a:t>
-            </a:r>
-          </a:p>
-          <a:p>
-            <a:pPr lvl="0"/>
-            <a:r>
-              <a:t>Clear written communication</a:t>
-            </a:r>
-          </a:p>
-          <a:p>
-            <a:pPr lvl="0"/>
-            <a:r>
-              <a:t>Domain expertise</a:t>
-            </a:r>
-          </a:p>
-          <a:p>
-            <a:pPr lvl="0"/>
-            <a:r>
-              <a:t>Security and risk assessment</a:t>
-            </a:r>
-          </a:p>
-          <a:p>
-            <a:pPr lvl="0"/>
-            <a:r>
-              <a:t>Product sense and user empathy</a:t>
-            </a:r>
-          </a:p>
-          <a:p>
-            <a:pPr lvl="0"/>
-            <a:r>
-              <a:t>Cross-functional fluency</a:t>
-            </a:r>
-          </a:p>
-          <a:p>
-            <a:pPr marL="0" lvl="0" indent="0">
-              <a:spcBef>
-                <a:spcPts val="3000"/>
-              </a:spcBef>
-              <a:buNone/>
-            </a:pPr>
-            <a:r>
-              <a:rPr b="1"/>
-              <a:t>Decreasing in value</a:t>
-            </a:r>
-          </a:p>
-          <a:p>
-            <a:pPr lvl="0"/>
-            <a:r>
-              <a:t>Syntax memorization</a:t>
-            </a:r>
-          </a:p>
-          <a:p>
-            <a:pPr lvl="0"/>
-            <a:r>
-              <a:t>Boilerplate implementation</a:t>
-            </a:r>
-          </a:p>
-          <a:p>
-            <a:pPr lvl="0"/>
-            <a:r>
-              <a:t>Manual code translation between languages</a:t>
-            </a:r>
-          </a:p>
-          <a:p>
-            <a:pPr lvl="0"/>
-            <a:r>
-              <a:t>Routine debugging of common errors</a:t>
-            </a:r>
-          </a:p>
-          <a:p>
-            <a:pPr lvl="0"/>
-            <a:r>
-              <a:t>Documentation writing for well-known patterns</a:t>
-            </a:r>
-          </a:p>
-          <a:p>
-            <a:pPr marL="0" lvl="0" indent="0">
-              <a:spcBef>
-                <a:spcPts val="3000"/>
-              </a:spcBef>
-              <a:buNone/>
-            </a:pPr>
-            <a:r>
-              <a:rPr b="1"/>
-              <a:t>Remaining important</a:t>
-            </a:r>
-          </a:p>
-          <a:p>
-            <a:pPr lvl="0"/>
-            <a:r>
-              <a:t>Debugging novel issues</a:t>
-            </a:r>
-          </a:p>
-          <a:p>
-            <a:pPr lvl="0"/>
-            <a:r>
-              <a:t>Performance optimization</a:t>
-            </a:r>
-          </a:p>
-          <a:p>
-            <a:pPr lvl="0"/>
-            <a:r>
-              <a:t>Infrastructure work</a:t>
-            </a:r>
-          </a:p>
-          <a:p>
-            <a:pPr lvl="0"/>
-            <a:r>
-              <a:t>Understanding legacy systems</a:t>
-            </a:r>
-          </a:p>
-          <a:p>
-            <a:pPr lvl="0"/>
-            <a:r>
-              <a:t>Mentoring and technical leadership</a:t>
-            </a:r>
-          </a:p>
-          <a:p>
-            <a:pPr marL="0" lvl="0" indent="0">
-              <a:buNone/>
-            </a:pPr>
-            <a:r>
-              <a:t>The pattern is consistent: anything requiring judgment, context, or creativity becomes more valuable. Anything that can be specified precisely becomes more automatable.</a:t>
+              <a:buNone/>
+            </a:pPr>
+            <a:r>
+              <a:t>The biggest shift underway is not better autocomplete. It is autonomous agents: AI systems that can plan, execute, and iterate with relatively little human intervention.</a:t>
+            </a:r>
+          </a:p>
+          <a:p>
+            <a:pPr marL="0" lvl="0" indent="0">
+              <a:buNone/>
+            </a:pPr>
+            <a:r>
+              <a:t>Examples already in the market include:</a:t>
+            </a:r>
+          </a:p>
+          <a:p>
+            <a:pPr lvl="0"/>
+            <a:r>
+              <a:t>Claude Code reading a codebase, planning multi-step work, writing code, running tests, and fixing failures</a:t>
+            </a:r>
+          </a:p>
+          <a:p>
+            <a:pPr lvl="0"/>
+            <a:r>
+              <a:t>GitHub Copilot launching parallel subagents through </a:t>
+            </a:r>
+            <a:r>
+              <a:rPr>
+                <a:latin typeface="Courier"/>
+              </a:rPr>
+              <a:t>/fleet</a:t>
+            </a:r>
+          </a:p>
+          <a:p>
+            <a:pPr lvl="0"/>
+            <a:r>
+              <a:t>Replit Agent building, testing, and deploying full applications</a:t>
+            </a:r>
+          </a:p>
+          <a:p>
+            <a:pPr marL="0" lvl="0" indent="0">
+              <a:buNone/>
+            </a:pPr>
+            <a:r>
+              <a:t>This is fundamentally different from autocomplete. Autocomplete helps you type faster. Agents do the work.</a:t>
+            </a:r>
+          </a:p>
+          <a:p>
+            <a:pPr marL="0" lvl="0" indent="0">
+              <a:buNone/>
+            </a:pPr>
+            <a:r>
+              <a:t>The human role shifts toward defining goals, reviewing results, and course-correcting.</a:t>
             </a:r>
           </a:p>
         </p:txBody>
@@ -14659,7 +15108,7 @@
               <a:buNone/>
             </a:pPr>
             <a:r>
-              <a:t>The Job Market</a:t>
+              <a:t>What Skills Will Matter</a:t>
             </a:r>
           </a:p>
         </p:txBody>
@@ -14677,17 +15126,9 @@
         <p:spPr/>
         <p:txBody>
           <a:bodyPr>
-            <a:normAutofit fontScale="47500" lnSpcReduction="20000"/>
+            <a:normAutofit fontScale="40000" lnSpcReduction="20000"/>
           </a:bodyPr>
           <a:lstStyle/>
-          <a:p>
-            <a:pPr marL="0" lvl="0" indent="0">
-              <a:buNone/>
-            </a:pPr>
-            <a:r>
-              <a:t>Some jobs will shrink. Others will grow. Many will be transformed.</a:t>
-            </a:r>
-          </a:p>
           <a:p>
             <a:pPr marL="0" lvl="0" indent="0">
               <a:spcBef>
@@ -14697,25 +15138,49 @@
             </a:pPr>
             <a:r>
               <a:rPr b="1"/>
-              <a:t>Roles most at risk of reduction</a:t>
-            </a:r>
-          </a:p>
-          <a:p>
-            <a:pPr lvl="0"/>
-            <a:r>
-              <a:t>Junior developers doing mostly CRUD and boilerplate work</a:t>
-            </a:r>
-          </a:p>
-          <a:p>
-            <a:pPr lvl="0"/>
-            <a:r>
-              <a:t>Manual QA testers</a:t>
-            </a:r>
-          </a:p>
-          <a:p>
-            <a:pPr lvl="0"/>
-            <a:r>
-              <a:t>Simple web development agencies competing directly with browser builders</a:t>
+              <a:t>Increasing in value</a:t>
+            </a:r>
+          </a:p>
+          <a:p>
+            <a:pPr lvl="0"/>
+            <a:r>
+              <a:t>Systems thinking and architecture</a:t>
+            </a:r>
+          </a:p>
+          <a:p>
+            <a:pPr lvl="0"/>
+            <a:r>
+              <a:t>Problem decomposition</a:t>
+            </a:r>
+          </a:p>
+          <a:p>
+            <a:pPr lvl="0"/>
+            <a:r>
+              <a:t>Clear written communication</a:t>
+            </a:r>
+          </a:p>
+          <a:p>
+            <a:pPr lvl="0"/>
+            <a:r>
+              <a:t>Domain expertise</a:t>
+            </a:r>
+          </a:p>
+          <a:p>
+            <a:pPr lvl="0"/>
+            <a:r>
+              <a:t>Security and risk assessment</a:t>
+            </a:r>
+          </a:p>
+          <a:p>
+            <a:pPr lvl="0"/>
+            <a:r>
+              <a:t>Product sense and user empathy</a:t>
+            </a:r>
+          </a:p>
+          <a:p>
+            <a:pPr lvl="0"/>
+            <a:r>
+              <a:t>Cross-functional fluency</a:t>
             </a:r>
           </a:p>
           <a:p>
@@ -14727,37 +15192,37 @@
             </a:pPr>
             <a:r>
               <a:rPr b="1"/>
-              <a:t>Roles likely to grow</a:t>
-            </a:r>
-          </a:p>
-          <a:p>
-            <a:pPr lvl="0"/>
-            <a:r>
-              <a:t>AI-assisted development specialists</a:t>
-            </a:r>
-          </a:p>
-          <a:p>
-            <a:pPr lvl="0"/>
-            <a:r>
-              <a:t>Security engineers</a:t>
-            </a:r>
-          </a:p>
-          <a:p>
-            <a:pPr lvl="0"/>
-            <a:r>
-              <a:t>Product managers who can prototype</a:t>
-            </a:r>
-          </a:p>
-          <a:p>
-            <a:pPr lvl="0"/>
-            <a:r>
-              <a:t>AI tool evaluators and integrators</a:t>
-            </a:r>
-          </a:p>
-          <a:p>
-            <a:pPr lvl="0"/>
-            <a:r>
-              <a:t>Technical reviewers and auditors</a:t>
+              <a:t>Decreasing in value</a:t>
+            </a:r>
+          </a:p>
+          <a:p>
+            <a:pPr lvl="0"/>
+            <a:r>
+              <a:t>Syntax memorization</a:t>
+            </a:r>
+          </a:p>
+          <a:p>
+            <a:pPr lvl="0"/>
+            <a:r>
+              <a:t>Boilerplate implementation</a:t>
+            </a:r>
+          </a:p>
+          <a:p>
+            <a:pPr lvl="0"/>
+            <a:r>
+              <a:t>Manual code translation between languages</a:t>
+            </a:r>
+          </a:p>
+          <a:p>
+            <a:pPr lvl="0"/>
+            <a:r>
+              <a:t>Routine debugging of common errors</a:t>
+            </a:r>
+          </a:p>
+          <a:p>
+            <a:pPr lvl="0"/>
+            <a:r>
+              <a:t>Documentation writing for well-known patterns</a:t>
             </a:r>
           </a:p>
           <a:p>
@@ -14769,33 +15234,45 @@
             </a:pPr>
             <a:r>
               <a:rPr b="1"/>
-              <a:t>Roles that transform</a:t>
-            </a:r>
-          </a:p>
-          <a:p>
-            <a:pPr lvl="0"/>
-            <a:r>
-              <a:t>Senior developers become architect-reviewers</a:t>
-            </a:r>
-          </a:p>
-          <a:p>
-            <a:pPr lvl="0"/>
-            <a:r>
-              <a:t>DevOps engineers become platform engineers for AI-augmented pipelines</a:t>
-            </a:r>
-          </a:p>
-          <a:p>
-            <a:pPr lvl="0"/>
-            <a:r>
-              <a:t>Technical writers become prompt and specification specialists</a:t>
-            </a:r>
-          </a:p>
-          <a:p>
-            <a:pPr marL="0" lvl="0" indent="0">
-              <a:buNone/>
-            </a:pPr>
-            <a:r>
-              <a:t>Automation usually eliminates tasks before it eliminates jobs. Vibe coding appears to be following that pattern.</a:t>
+              <a:t>Remaining important</a:t>
+            </a:r>
+          </a:p>
+          <a:p>
+            <a:pPr lvl="0"/>
+            <a:r>
+              <a:t>Debugging novel issues</a:t>
+            </a:r>
+          </a:p>
+          <a:p>
+            <a:pPr lvl="0"/>
+            <a:r>
+              <a:t>Performance optimization</a:t>
+            </a:r>
+          </a:p>
+          <a:p>
+            <a:pPr lvl="0"/>
+            <a:r>
+              <a:t>Infrastructure work</a:t>
+            </a:r>
+          </a:p>
+          <a:p>
+            <a:pPr lvl="0"/>
+            <a:r>
+              <a:t>Understanding legacy systems</a:t>
+            </a:r>
+          </a:p>
+          <a:p>
+            <a:pPr lvl="0"/>
+            <a:r>
+              <a:t>Mentoring and technical leadership</a:t>
+            </a:r>
+          </a:p>
+          <a:p>
+            <a:pPr marL="0" lvl="0" indent="0">
+              <a:buNone/>
+            </a:pPr>
+            <a:r>
+              <a:t>The pattern is consistent: anything requiring judgment, context, or creativity becomes more valuable. Anything that can be specified precisely becomes more automatable.</a:t>
             </a:r>
           </a:p>
         </p:txBody>
@@ -14844,7 +15321,7 @@
               <a:buNone/>
             </a:pPr>
             <a:r>
-              <a:t>The 10x Solo Founder</a:t>
+              <a:t>The Job Market</a:t>
             </a:r>
           </a:p>
         </p:txBody>
@@ -14861,30 +15338,126 @@
         </p:nvSpPr>
         <p:spPr/>
         <p:txBody>
-          <a:bodyPr/>
+          <a:bodyPr>
+            <a:normAutofit fontScale="47500" lnSpcReduction="20000"/>
+          </a:bodyPr>
           <a:lstStyle/>
           <a:p>
             <a:pPr marL="0" lvl="0" indent="0">
               <a:buNone/>
             </a:pPr>
             <a:r>
-              <a:t>One of the most visible effects is that individuals can now build what once required teams. The ceiling of what one competent person can build with AI keeps rising.</a:t>
-            </a:r>
-          </a:p>
-          <a:p>
-            <a:pPr marL="0" lvl="0" indent="0">
-              <a:buNone/>
-            </a:pPr>
-            <a:r>
-              <a:t>That matters for startups and for large organizations. Small empowered teams with AI can often move faster than much larger traditional teams.</a:t>
-            </a:r>
-          </a:p>
-          <a:p>
-            <a:pPr marL="0" lvl="0" indent="0">
-              <a:buNone/>
-            </a:pPr>
-            <a:r>
-              <a:t>But there are still hard limits around support, operations, legal work, partnerships, and scale.</a:t>
+              <a:t>Some jobs will shrink. Others will grow. Many will be transformed.</a:t>
+            </a:r>
+          </a:p>
+          <a:p>
+            <a:pPr marL="0" lvl="0" indent="0">
+              <a:spcBef>
+                <a:spcPts val="3000"/>
+              </a:spcBef>
+              <a:buNone/>
+            </a:pPr>
+            <a:r>
+              <a:rPr b="1"/>
+              <a:t>Roles most at risk of reduction</a:t>
+            </a:r>
+          </a:p>
+          <a:p>
+            <a:pPr lvl="0"/>
+            <a:r>
+              <a:t>Junior developers doing mostly CRUD and boilerplate work</a:t>
+            </a:r>
+          </a:p>
+          <a:p>
+            <a:pPr lvl="0"/>
+            <a:r>
+              <a:t>Manual QA testers</a:t>
+            </a:r>
+          </a:p>
+          <a:p>
+            <a:pPr lvl="0"/>
+            <a:r>
+              <a:t>Simple web development agencies competing directly with browser builders</a:t>
+            </a:r>
+          </a:p>
+          <a:p>
+            <a:pPr marL="0" lvl="0" indent="0">
+              <a:spcBef>
+                <a:spcPts val="3000"/>
+              </a:spcBef>
+              <a:buNone/>
+            </a:pPr>
+            <a:r>
+              <a:rPr b="1"/>
+              <a:t>Roles likely to grow</a:t>
+            </a:r>
+          </a:p>
+          <a:p>
+            <a:pPr lvl="0"/>
+            <a:r>
+              <a:t>AI-assisted development specialists</a:t>
+            </a:r>
+          </a:p>
+          <a:p>
+            <a:pPr lvl="0"/>
+            <a:r>
+              <a:t>Security engineers</a:t>
+            </a:r>
+          </a:p>
+          <a:p>
+            <a:pPr lvl="0"/>
+            <a:r>
+              <a:t>Product managers who can prototype</a:t>
+            </a:r>
+          </a:p>
+          <a:p>
+            <a:pPr lvl="0"/>
+            <a:r>
+              <a:t>AI tool evaluators and integrators</a:t>
+            </a:r>
+          </a:p>
+          <a:p>
+            <a:pPr lvl="0"/>
+            <a:r>
+              <a:t>Technical reviewers and auditors</a:t>
+            </a:r>
+          </a:p>
+          <a:p>
+            <a:pPr marL="0" lvl="0" indent="0">
+              <a:spcBef>
+                <a:spcPts val="3000"/>
+              </a:spcBef>
+              <a:buNone/>
+            </a:pPr>
+            <a:r>
+              <a:rPr b="1"/>
+              <a:t>Roles that transform</a:t>
+            </a:r>
+          </a:p>
+          <a:p>
+            <a:pPr lvl="0"/>
+            <a:r>
+              <a:t>Senior developers become architect-reviewers</a:t>
+            </a:r>
+          </a:p>
+          <a:p>
+            <a:pPr lvl="0"/>
+            <a:r>
+              <a:t>DevOps engineers become platform engineers for AI-augmented pipelines</a:t>
+            </a:r>
+          </a:p>
+          <a:p>
+            <a:pPr lvl="0"/>
+            <a:r>
+              <a:t>Technical writers become prompt and specification specialists</a:t>
+            </a:r>
+          </a:p>
+          <a:p>
+            <a:pPr marL="0" lvl="0" indent="0">
+              <a:buNone/>
+            </a:pPr>
+            <a:r>
+              <a:t>Automation usually eliminates tasks before it eliminates jobs. Vibe coding appears to be following that pattern.</a:t>
             </a:r>
           </a:p>
         </p:txBody>
@@ -14933,7 +15506,7 @@
               <a:buNone/>
             </a:pPr>
             <a:r>
-              <a:t>Risks of Over-Reliance</a:t>
+              <a:t>The 10x Solo Founder</a:t>
             </a:r>
           </a:p>
         </p:txBody>
@@ -14957,31 +15530,23 @@
               <a:buNone/>
             </a:pPr>
             <a:r>
-              <a:t>This trajectory is not purely positive. There are real risks:</a:t>
-            </a:r>
-          </a:p>
-          <a:p>
-            <a:pPr lvl="0"/>
-            <a:r>
-              <a:t>Knowledge atrophy if developers stop learning what the AI is actually doing</a:t>
-            </a:r>
-          </a:p>
-          <a:p>
-            <a:pPr lvl="0"/>
-            <a:r>
-              <a:t>Vendor dependency on a small set of tools and providers</a:t>
-            </a:r>
-          </a:p>
-          <a:p>
-            <a:pPr lvl="0"/>
-            <a:r>
-              <a:t>Monoculture risk when everyone ships the same patterns and weaknesses</a:t>
-            </a:r>
-          </a:p>
-          <a:p>
-            <a:pPr lvl="0"/>
-            <a:r>
-              <a:t>The “good enough” trap, where systems ship at 90% quality and fail in the last 10%</a:t>
+              <a:t>One of the most visible effects is that individuals can now build what once required teams. The ceiling of what one competent person can build with AI keeps rising.</a:t>
+            </a:r>
+          </a:p>
+          <a:p>
+            <a:pPr marL="0" lvl="0" indent="0">
+              <a:buNone/>
+            </a:pPr>
+            <a:r>
+              <a:t>That matters for startups and for large organizations. Small empowered teams with AI can often move faster than much larger traditional teams.</a:t>
+            </a:r>
+          </a:p>
+          <a:p>
+            <a:pPr marL="0" lvl="0" indent="0">
+              <a:buNone/>
+            </a:pPr>
+            <a:r>
+              <a:t>But there are still hard limits around support, operations, legal work, partnerships, and scale.</a:t>
             </a:r>
           </a:p>
         </p:txBody>
@@ -14995,6 +15560,103 @@
 </file>
 
 <file path=ppt/slides/slide74.xml><?xml version="1.0" encoding="utf-8"?>
+<p:sld xmlns:a="http://schemas.openxmlformats.org/drawingml/2006/main" xmlns:r="http://schemas.openxmlformats.org/officeDocument/2006/relationships" xmlns:p="http://schemas.openxmlformats.org/presentationml/2006/main">
+  <p:cSld>
+    <p:spTree>
+      <p:nvGrpSpPr>
+        <p:cNvPr id="1" name=""/>
+        <p:cNvGrpSpPr/>
+        <p:nvPr/>
+      </p:nvGrpSpPr>
+      <p:grpSpPr>
+        <a:xfrm>
+          <a:off x="0" y="0"/>
+          <a:ext cx="0" cy="0"/>
+          <a:chOff x="0" y="0"/>
+          <a:chExt cx="0" cy="0"/>
+        </a:xfrm>
+      </p:grpSpPr>
+      <p:sp>
+        <p:nvSpPr>
+          <p:cNvPr id="2" name="Title 1"/>
+          <p:cNvSpPr>
+            <a:spLocks noGrp="1"/>
+          </p:cNvSpPr>
+          <p:nvPr>
+            <p:ph type="title"/>
+          </p:nvPr>
+        </p:nvSpPr>
+        <p:spPr/>
+        <p:txBody>
+          <a:bodyPr/>
+          <a:lstStyle/>
+          <a:p>
+            <a:pPr marL="0" lvl="0" indent="0">
+              <a:buNone/>
+            </a:pPr>
+            <a:r>
+              <a:t>Risks of Over-Reliance</a:t>
+            </a:r>
+          </a:p>
+        </p:txBody>
+      </p:sp>
+      <p:sp>
+        <p:nvSpPr>
+          <p:cNvPr id="3" name="Content Placeholder 2"/>
+          <p:cNvSpPr>
+            <a:spLocks noGrp="1"/>
+          </p:cNvSpPr>
+          <p:nvPr>
+            <p:ph idx="1"/>
+          </p:nvPr>
+        </p:nvSpPr>
+        <p:spPr/>
+        <p:txBody>
+          <a:bodyPr/>
+          <a:lstStyle/>
+          <a:p>
+            <a:pPr marL="0" lvl="0" indent="0">
+              <a:buNone/>
+            </a:pPr>
+            <a:r>
+              <a:t>This trajectory is not purely positive. There are real risks:</a:t>
+            </a:r>
+          </a:p>
+          <a:p>
+            <a:pPr lvl="0"/>
+            <a:r>
+              <a:t>Knowledge atrophy if developers stop learning what the AI is actually doing</a:t>
+            </a:r>
+          </a:p>
+          <a:p>
+            <a:pPr lvl="0"/>
+            <a:r>
+              <a:t>Vendor dependency on a small set of tools and providers</a:t>
+            </a:r>
+          </a:p>
+          <a:p>
+            <a:pPr lvl="0"/>
+            <a:r>
+              <a:t>Monoculture risk when everyone ships the same patterns and weaknesses</a:t>
+            </a:r>
+          </a:p>
+          <a:p>
+            <a:pPr lvl="0"/>
+            <a:r>
+              <a:t>The “good enough” trap, where systems ship at 90% quality and fail in the last 10%</a:t>
+            </a:r>
+          </a:p>
+        </p:txBody>
+      </p:sp>
+    </p:spTree>
+  </p:cSld>
+  <p:clrMapOvr>
+    <a:masterClrMapping/>
+  </p:clrMapOvr>
+</p:sld>
+</file>
+
+<file path=ppt/slides/slide75.xml><?xml version="1.0" encoding="utf-8"?>
 <p:sld xmlns:a="http://schemas.openxmlformats.org/drawingml/2006/main" xmlns:r="http://schemas.openxmlformats.org/officeDocument/2006/relationships" xmlns:p="http://schemas.openxmlformats.org/presentationml/2006/main">
   <p:cSld>
     <p:spTree>

</xml_diff>